<commit_message>
docs(deliverables): update the Second Review deck with manual edits
Co-Authored-By: Claude Opus 5.5 <noreply@anthropic.com>
</commit_message>
<xml_diff>
--- a/deliverables/review-2/semantic-communication-second-review.pptx
+++ b/deliverables/review-2/semantic-communication-second-review.pptx
@@ -5,28 +5,28 @@
     <p:sldMasterId id="2147483648" r:id="rId1"/>
   </p:sldMasterIdLst>
   <p:sldIdLst>
-    <p:sldId id="256" r:id="rId7"/>
-    <p:sldId id="257" r:id="rId8"/>
-    <p:sldId id="258" r:id="rId9"/>
-    <p:sldId id="259" r:id="rId10"/>
-    <p:sldId id="260" r:id="rId11"/>
-    <p:sldId id="261" r:id="rId12"/>
-    <p:sldId id="262" r:id="rId13"/>
-    <p:sldId id="263" r:id="rId14"/>
-    <p:sldId id="264" r:id="rId15"/>
-    <p:sldId id="265" r:id="rId16"/>
-    <p:sldId id="266" r:id="rId17"/>
-    <p:sldId id="267" r:id="rId18"/>
-    <p:sldId id="268" r:id="rId19"/>
-    <p:sldId id="269" r:id="rId20"/>
-    <p:sldId id="270" r:id="rId21"/>
-    <p:sldId id="271" r:id="rId22"/>
-    <p:sldId id="272" r:id="rId23"/>
-    <p:sldId id="273" r:id="rId24"/>
-    <p:sldId id="274" r:id="rId25"/>
-    <p:sldId id="275" r:id="rId26"/>
+    <p:sldId id="256" r:id="rId2"/>
+    <p:sldId id="257" r:id="rId3"/>
+    <p:sldId id="258" r:id="rId4"/>
+    <p:sldId id="259" r:id="rId5"/>
+    <p:sldId id="260" r:id="rId6"/>
+    <p:sldId id="261" r:id="rId7"/>
+    <p:sldId id="262" r:id="rId8"/>
+    <p:sldId id="263" r:id="rId9"/>
+    <p:sldId id="264" r:id="rId10"/>
+    <p:sldId id="265" r:id="rId11"/>
+    <p:sldId id="266" r:id="rId12"/>
+    <p:sldId id="267" r:id="rId13"/>
+    <p:sldId id="268" r:id="rId14"/>
+    <p:sldId id="269" r:id="rId15"/>
+    <p:sldId id="270" r:id="rId16"/>
+    <p:sldId id="271" r:id="rId17"/>
+    <p:sldId id="272" r:id="rId18"/>
+    <p:sldId id="273" r:id="rId19"/>
+    <p:sldId id="274" r:id="rId20"/>
+    <p:sldId id="275" r:id="rId21"/>
   </p:sldIdLst>
-  <p:sldSz cx="12191695" cy="6858000" type="screen4x3"/>
+  <p:sldSz cx="12192000" cy="6858000"/>
   <p:notesSz cx="6858000" cy="9144000"/>
   <p:defaultTextStyle>
     <a:defPPr>
@@ -123,6 +123,22 @@
       </a:defRPr>
     </a:lvl9pPr>
   </p:defaultTextStyle>
+  <p:extLst>
+    <p:ext uri="{EFAFB233-063F-42B5-8137-9DF3F51BA10A}">
+      <p15:sldGuideLst xmlns:p15="http://schemas.microsoft.com/office/powerpoint/2012/main">
+        <p15:guide id="1" orient="horz" pos="2160">
+          <p15:clr>
+            <a:srgbClr val="A4A3A4"/>
+          </p15:clr>
+        </p15:guide>
+        <p15:guide id="2" pos="2880">
+          <p15:clr>
+            <a:srgbClr val="A4A3A4"/>
+          </p15:clr>
+        </p15:guide>
+      </p15:sldGuideLst>
+    </p:ext>
+  </p:extLst>
 </p:presentation>
 </file>
 
@@ -164,10 +180,9 @@
           <a:lstStyle/>
           <a:p>
             <a:r>
-              <a:rPr lang="en-US" smtClean="0"/>
+              <a:rPr lang="en-US"/>
               <a:t>Click to edit Master title style</a:t>
             </a:r>
-            <a:endParaRPr lang="en-US"/>
           </a:p>
         </p:txBody>
       </p:sp>
@@ -283,10 +298,9 @@
           </a:lstStyle>
           <a:p>
             <a:r>
-              <a:rPr lang="en-US" smtClean="0"/>
+              <a:rPr lang="en-US"/>
               <a:t>Click to edit Master subtitle style</a:t>
             </a:r>
-            <a:endParaRPr lang="en-US"/>
           </a:p>
         </p:txBody>
       </p:sp>
@@ -307,7 +321,7 @@
           <a:p>
             <a:fld id="{5BCAD085-E8A6-8845-BD4E-CB4CCA059FC4}" type="datetimeFigureOut">
               <a:rPr lang="en-US" smtClean="0"/>
-              <a:t>1/27/13</a:t>
+              <a:t>9/30/2026</a:t>
             </a:fld>
             <a:endParaRPr lang="en-US"/>
           </a:p>
@@ -401,10 +415,9 @@
           <a:lstStyle/>
           <a:p>
             <a:r>
-              <a:rPr lang="en-US" smtClean="0"/>
+              <a:rPr lang="en-US"/>
               <a:t>Click to edit Master title style</a:t>
             </a:r>
-            <a:endParaRPr lang="en-US"/>
           </a:p>
         </p:txBody>
       </p:sp>
@@ -425,38 +438,37 @@
           <a:p>
             <a:pPr lvl="0"/>
             <a:r>
-              <a:rPr lang="en-US" smtClean="0"/>
+              <a:rPr lang="en-US"/>
               <a:t>Click to edit Master text styles</a:t>
             </a:r>
           </a:p>
           <a:p>
             <a:pPr lvl="1"/>
             <a:r>
-              <a:rPr lang="en-US" smtClean="0"/>
+              <a:rPr lang="en-US"/>
               <a:t>Second level</a:t>
             </a:r>
           </a:p>
           <a:p>
             <a:pPr lvl="2"/>
             <a:r>
-              <a:rPr lang="en-US" smtClean="0"/>
+              <a:rPr lang="en-US"/>
               <a:t>Third level</a:t>
             </a:r>
           </a:p>
           <a:p>
             <a:pPr lvl="3"/>
             <a:r>
-              <a:rPr lang="en-US" smtClean="0"/>
+              <a:rPr lang="en-US"/>
               <a:t>Fourth level</a:t>
             </a:r>
           </a:p>
           <a:p>
             <a:pPr lvl="4"/>
             <a:r>
-              <a:rPr lang="en-US" smtClean="0"/>
+              <a:rPr lang="en-US"/>
               <a:t>Fifth level</a:t>
             </a:r>
-            <a:endParaRPr lang="en-US"/>
           </a:p>
         </p:txBody>
       </p:sp>
@@ -477,7 +489,7 @@
           <a:p>
             <a:fld id="{5BCAD085-E8A6-8845-BD4E-CB4CCA059FC4}" type="datetimeFigureOut">
               <a:rPr lang="en-US" smtClean="0"/>
-              <a:t>1/27/13</a:t>
+              <a:t>9/30/2026</a:t>
             </a:fld>
             <a:endParaRPr lang="en-US"/>
           </a:p>
@@ -576,10 +588,9 @@
           <a:lstStyle/>
           <a:p>
             <a:r>
-              <a:rPr lang="en-US" smtClean="0"/>
+              <a:rPr lang="en-US"/>
               <a:t>Click to edit Master title style</a:t>
             </a:r>
-            <a:endParaRPr lang="en-US"/>
           </a:p>
         </p:txBody>
       </p:sp>
@@ -605,38 +616,37 @@
           <a:p>
             <a:pPr lvl="0"/>
             <a:r>
-              <a:rPr lang="en-US" smtClean="0"/>
+              <a:rPr lang="en-US"/>
               <a:t>Click to edit Master text styles</a:t>
             </a:r>
           </a:p>
           <a:p>
             <a:pPr lvl="1"/>
             <a:r>
-              <a:rPr lang="en-US" smtClean="0"/>
+              <a:rPr lang="en-US"/>
               <a:t>Second level</a:t>
             </a:r>
           </a:p>
           <a:p>
             <a:pPr lvl="2"/>
             <a:r>
-              <a:rPr lang="en-US" smtClean="0"/>
+              <a:rPr lang="en-US"/>
               <a:t>Third level</a:t>
             </a:r>
           </a:p>
           <a:p>
             <a:pPr lvl="3"/>
             <a:r>
-              <a:rPr lang="en-US" smtClean="0"/>
+              <a:rPr lang="en-US"/>
               <a:t>Fourth level</a:t>
             </a:r>
           </a:p>
           <a:p>
             <a:pPr lvl="4"/>
             <a:r>
-              <a:rPr lang="en-US" smtClean="0"/>
+              <a:rPr lang="en-US"/>
               <a:t>Fifth level</a:t>
             </a:r>
-            <a:endParaRPr lang="en-US"/>
           </a:p>
         </p:txBody>
       </p:sp>
@@ -657,7 +667,7 @@
           <a:p>
             <a:fld id="{5BCAD085-E8A6-8845-BD4E-CB4CCA059FC4}" type="datetimeFigureOut">
               <a:rPr lang="en-US" smtClean="0"/>
-              <a:t>1/27/13</a:t>
+              <a:t>9/30/2026</a:t>
             </a:fld>
             <a:endParaRPr lang="en-US"/>
           </a:p>
@@ -751,10 +761,9 @@
           <a:lstStyle/>
           <a:p>
             <a:r>
-              <a:rPr lang="en-US" smtClean="0"/>
+              <a:rPr lang="en-US"/>
               <a:t>Click to edit Master title style</a:t>
             </a:r>
-            <a:endParaRPr lang="en-US"/>
           </a:p>
         </p:txBody>
       </p:sp>
@@ -775,38 +784,37 @@
           <a:p>
             <a:pPr lvl="0"/>
             <a:r>
-              <a:rPr lang="en-US" smtClean="0"/>
+              <a:rPr lang="en-US"/>
               <a:t>Click to edit Master text styles</a:t>
             </a:r>
           </a:p>
           <a:p>
             <a:pPr lvl="1"/>
             <a:r>
-              <a:rPr lang="en-US" smtClean="0"/>
+              <a:rPr lang="en-US"/>
               <a:t>Second level</a:t>
             </a:r>
           </a:p>
           <a:p>
             <a:pPr lvl="2"/>
             <a:r>
-              <a:rPr lang="en-US" smtClean="0"/>
+              <a:rPr lang="en-US"/>
               <a:t>Third level</a:t>
             </a:r>
           </a:p>
           <a:p>
             <a:pPr lvl="3"/>
             <a:r>
-              <a:rPr lang="en-US" smtClean="0"/>
+              <a:rPr lang="en-US"/>
               <a:t>Fourth level</a:t>
             </a:r>
           </a:p>
           <a:p>
             <a:pPr lvl="4"/>
             <a:r>
-              <a:rPr lang="en-US" smtClean="0"/>
+              <a:rPr lang="en-US"/>
               <a:t>Fifth level</a:t>
             </a:r>
-            <a:endParaRPr lang="en-US"/>
           </a:p>
         </p:txBody>
       </p:sp>
@@ -827,7 +835,7 @@
           <a:p>
             <a:fld id="{5BCAD085-E8A6-8845-BD4E-CB4CCA059FC4}" type="datetimeFigureOut">
               <a:rPr lang="en-US" smtClean="0"/>
-              <a:t>1/27/13</a:t>
+              <a:t>9/30/2026</a:t>
             </a:fld>
             <a:endParaRPr lang="en-US"/>
           </a:p>
@@ -930,10 +938,9 @@
           </a:lstStyle>
           <a:p>
             <a:r>
-              <a:rPr lang="en-US" smtClean="0"/>
+              <a:rPr lang="en-US"/>
               <a:t>Click to edit Master title style</a:t>
             </a:r>
-            <a:endParaRPr lang="en-US"/>
           </a:p>
         </p:txBody>
       </p:sp>
@@ -1050,7 +1057,7 @@
           <a:p>
             <a:pPr lvl="0"/>
             <a:r>
-              <a:rPr lang="en-US" smtClean="0"/>
+              <a:rPr lang="en-US"/>
               <a:t>Click to edit Master text styles</a:t>
             </a:r>
           </a:p>
@@ -1073,7 +1080,7 @@
           <a:p>
             <a:fld id="{5BCAD085-E8A6-8845-BD4E-CB4CCA059FC4}" type="datetimeFigureOut">
               <a:rPr lang="en-US" smtClean="0"/>
-              <a:t>1/27/13</a:t>
+              <a:t>9/30/2026</a:t>
             </a:fld>
             <a:endParaRPr lang="en-US"/>
           </a:p>
@@ -1167,10 +1174,9 @@
           <a:lstStyle/>
           <a:p>
             <a:r>
-              <a:rPr lang="en-US" smtClean="0"/>
+              <a:rPr lang="en-US"/>
               <a:t>Click to edit Master title style</a:t>
             </a:r>
-            <a:endParaRPr lang="en-US"/>
           </a:p>
         </p:txBody>
       </p:sp>
@@ -1224,38 +1230,37 @@
           <a:p>
             <a:pPr lvl="0"/>
             <a:r>
-              <a:rPr lang="en-US" smtClean="0"/>
+              <a:rPr lang="en-US"/>
               <a:t>Click to edit Master text styles</a:t>
             </a:r>
           </a:p>
           <a:p>
             <a:pPr lvl="1"/>
             <a:r>
-              <a:rPr lang="en-US" smtClean="0"/>
+              <a:rPr lang="en-US"/>
               <a:t>Second level</a:t>
             </a:r>
           </a:p>
           <a:p>
             <a:pPr lvl="2"/>
             <a:r>
-              <a:rPr lang="en-US" smtClean="0"/>
+              <a:rPr lang="en-US"/>
               <a:t>Third level</a:t>
             </a:r>
           </a:p>
           <a:p>
             <a:pPr lvl="3"/>
             <a:r>
-              <a:rPr lang="en-US" smtClean="0"/>
+              <a:rPr lang="en-US"/>
               <a:t>Fourth level</a:t>
             </a:r>
           </a:p>
           <a:p>
             <a:pPr lvl="4"/>
             <a:r>
-              <a:rPr lang="en-US" smtClean="0"/>
+              <a:rPr lang="en-US"/>
               <a:t>Fifth level</a:t>
             </a:r>
-            <a:endParaRPr lang="en-US"/>
           </a:p>
         </p:txBody>
       </p:sp>
@@ -1309,38 +1314,37 @@
           <a:p>
             <a:pPr lvl="0"/>
             <a:r>
-              <a:rPr lang="en-US" smtClean="0"/>
+              <a:rPr lang="en-US"/>
               <a:t>Click to edit Master text styles</a:t>
             </a:r>
           </a:p>
           <a:p>
             <a:pPr lvl="1"/>
             <a:r>
-              <a:rPr lang="en-US" smtClean="0"/>
+              <a:rPr lang="en-US"/>
               <a:t>Second level</a:t>
             </a:r>
           </a:p>
           <a:p>
             <a:pPr lvl="2"/>
             <a:r>
-              <a:rPr lang="en-US" smtClean="0"/>
+              <a:rPr lang="en-US"/>
               <a:t>Third level</a:t>
             </a:r>
           </a:p>
           <a:p>
             <a:pPr lvl="3"/>
             <a:r>
-              <a:rPr lang="en-US" smtClean="0"/>
+              <a:rPr lang="en-US"/>
               <a:t>Fourth level</a:t>
             </a:r>
           </a:p>
           <a:p>
             <a:pPr lvl="4"/>
             <a:r>
-              <a:rPr lang="en-US" smtClean="0"/>
+              <a:rPr lang="en-US"/>
               <a:t>Fifth level</a:t>
             </a:r>
-            <a:endParaRPr lang="en-US"/>
           </a:p>
         </p:txBody>
       </p:sp>
@@ -1361,7 +1365,7 @@
           <a:p>
             <a:fld id="{5BCAD085-E8A6-8845-BD4E-CB4CCA059FC4}" type="datetimeFigureOut">
               <a:rPr lang="en-US" smtClean="0"/>
-              <a:t>1/27/13</a:t>
+              <a:t>9/30/2026</a:t>
             </a:fld>
             <a:endParaRPr lang="en-US"/>
           </a:p>
@@ -1459,10 +1463,9 @@
           </a:lstStyle>
           <a:p>
             <a:r>
-              <a:rPr lang="en-US" smtClean="0"/>
+              <a:rPr lang="en-US"/>
               <a:t>Click to edit Master title style</a:t>
             </a:r>
-            <a:endParaRPr lang="en-US"/>
           </a:p>
         </p:txBody>
       </p:sp>
@@ -1525,7 +1528,7 @@
           <a:p>
             <a:pPr lvl="0"/>
             <a:r>
-              <a:rPr lang="en-US" smtClean="0"/>
+              <a:rPr lang="en-US"/>
               <a:t>Click to edit Master text styles</a:t>
             </a:r>
           </a:p>
@@ -1581,38 +1584,37 @@
           <a:p>
             <a:pPr lvl="0"/>
             <a:r>
-              <a:rPr lang="en-US" smtClean="0"/>
+              <a:rPr lang="en-US"/>
               <a:t>Click to edit Master text styles</a:t>
             </a:r>
           </a:p>
           <a:p>
             <a:pPr lvl="1"/>
             <a:r>
-              <a:rPr lang="en-US" smtClean="0"/>
+              <a:rPr lang="en-US"/>
               <a:t>Second level</a:t>
             </a:r>
           </a:p>
           <a:p>
             <a:pPr lvl="2"/>
             <a:r>
-              <a:rPr lang="en-US" smtClean="0"/>
+              <a:rPr lang="en-US"/>
               <a:t>Third level</a:t>
             </a:r>
           </a:p>
           <a:p>
             <a:pPr lvl="3"/>
             <a:r>
-              <a:rPr lang="en-US" smtClean="0"/>
+              <a:rPr lang="en-US"/>
               <a:t>Fourth level</a:t>
             </a:r>
           </a:p>
           <a:p>
             <a:pPr lvl="4"/>
             <a:r>
-              <a:rPr lang="en-US" smtClean="0"/>
+              <a:rPr lang="en-US"/>
               <a:t>Fifth level</a:t>
             </a:r>
-            <a:endParaRPr lang="en-US"/>
           </a:p>
         </p:txBody>
       </p:sp>
@@ -1675,7 +1677,7 @@
           <a:p>
             <a:pPr lvl="0"/>
             <a:r>
-              <a:rPr lang="en-US" smtClean="0"/>
+              <a:rPr lang="en-US"/>
               <a:t>Click to edit Master text styles</a:t>
             </a:r>
           </a:p>
@@ -1731,38 +1733,37 @@
           <a:p>
             <a:pPr lvl="0"/>
             <a:r>
-              <a:rPr lang="en-US" smtClean="0"/>
+              <a:rPr lang="en-US"/>
               <a:t>Click to edit Master text styles</a:t>
             </a:r>
           </a:p>
           <a:p>
             <a:pPr lvl="1"/>
             <a:r>
-              <a:rPr lang="en-US" smtClean="0"/>
+              <a:rPr lang="en-US"/>
               <a:t>Second level</a:t>
             </a:r>
           </a:p>
           <a:p>
             <a:pPr lvl="2"/>
             <a:r>
-              <a:rPr lang="en-US" smtClean="0"/>
+              <a:rPr lang="en-US"/>
               <a:t>Third level</a:t>
             </a:r>
           </a:p>
           <a:p>
             <a:pPr lvl="3"/>
             <a:r>
-              <a:rPr lang="en-US" smtClean="0"/>
+              <a:rPr lang="en-US"/>
               <a:t>Fourth level</a:t>
             </a:r>
           </a:p>
           <a:p>
             <a:pPr lvl="4"/>
             <a:r>
-              <a:rPr lang="en-US" smtClean="0"/>
+              <a:rPr lang="en-US"/>
               <a:t>Fifth level</a:t>
             </a:r>
-            <a:endParaRPr lang="en-US"/>
           </a:p>
         </p:txBody>
       </p:sp>
@@ -1783,7 +1784,7 @@
           <a:p>
             <a:fld id="{5BCAD085-E8A6-8845-BD4E-CB4CCA059FC4}" type="datetimeFigureOut">
               <a:rPr lang="en-US" smtClean="0"/>
-              <a:t>1/27/13</a:t>
+              <a:t>9/30/2026</a:t>
             </a:fld>
             <a:endParaRPr lang="en-US"/>
           </a:p>
@@ -1877,10 +1878,9 @@
           <a:lstStyle/>
           <a:p>
             <a:r>
-              <a:rPr lang="en-US" smtClean="0"/>
+              <a:rPr lang="en-US"/>
               <a:t>Click to edit Master title style</a:t>
             </a:r>
-            <a:endParaRPr lang="en-US"/>
           </a:p>
         </p:txBody>
       </p:sp>
@@ -1901,7 +1901,7 @@
           <a:p>
             <a:fld id="{5BCAD085-E8A6-8845-BD4E-CB4CCA059FC4}" type="datetimeFigureOut">
               <a:rPr lang="en-US" smtClean="0"/>
-              <a:t>1/27/13</a:t>
+              <a:t>9/30/2026</a:t>
             </a:fld>
             <a:endParaRPr lang="en-US"/>
           </a:p>
@@ -1996,7 +1996,7 @@
           <a:p>
             <a:fld id="{5BCAD085-E8A6-8845-BD4E-CB4CCA059FC4}" type="datetimeFigureOut">
               <a:rPr lang="en-US" smtClean="0"/>
-              <a:t>1/27/13</a:t>
+              <a:t>9/30/2026</a:t>
             </a:fld>
             <a:endParaRPr lang="en-US"/>
           </a:p>
@@ -2099,10 +2099,9 @@
           </a:lstStyle>
           <a:p>
             <a:r>
-              <a:rPr lang="en-US" smtClean="0"/>
+              <a:rPr lang="en-US"/>
               <a:t>Click to edit Master title style</a:t>
             </a:r>
-            <a:endParaRPr lang="en-US"/>
           </a:p>
         </p:txBody>
       </p:sp>
@@ -2156,38 +2155,37 @@
           <a:p>
             <a:pPr lvl="0"/>
             <a:r>
-              <a:rPr lang="en-US" smtClean="0"/>
+              <a:rPr lang="en-US"/>
               <a:t>Click to edit Master text styles</a:t>
             </a:r>
           </a:p>
           <a:p>
             <a:pPr lvl="1"/>
             <a:r>
-              <a:rPr lang="en-US" smtClean="0"/>
+              <a:rPr lang="en-US"/>
               <a:t>Second level</a:t>
             </a:r>
           </a:p>
           <a:p>
             <a:pPr lvl="2"/>
             <a:r>
-              <a:rPr lang="en-US" smtClean="0"/>
+              <a:rPr lang="en-US"/>
               <a:t>Third level</a:t>
             </a:r>
           </a:p>
           <a:p>
             <a:pPr lvl="3"/>
             <a:r>
-              <a:rPr lang="en-US" smtClean="0"/>
+              <a:rPr lang="en-US"/>
               <a:t>Fourth level</a:t>
             </a:r>
           </a:p>
           <a:p>
             <a:pPr lvl="4"/>
             <a:r>
-              <a:rPr lang="en-US" smtClean="0"/>
+              <a:rPr lang="en-US"/>
               <a:t>Fifth level</a:t>
             </a:r>
-            <a:endParaRPr lang="en-US"/>
           </a:p>
         </p:txBody>
       </p:sp>
@@ -2250,7 +2248,7 @@
           <a:p>
             <a:pPr lvl="0"/>
             <a:r>
-              <a:rPr lang="en-US" smtClean="0"/>
+              <a:rPr lang="en-US"/>
               <a:t>Click to edit Master text styles</a:t>
             </a:r>
           </a:p>
@@ -2273,7 +2271,7 @@
           <a:p>
             <a:fld id="{5BCAD085-E8A6-8845-BD4E-CB4CCA059FC4}" type="datetimeFigureOut">
               <a:rPr lang="en-US" smtClean="0"/>
-              <a:t>1/27/13</a:t>
+              <a:t>9/30/2026</a:t>
             </a:fld>
             <a:endParaRPr lang="en-US"/>
           </a:p>
@@ -2376,10 +2374,9 @@
           </a:lstStyle>
           <a:p>
             <a:r>
-              <a:rPr lang="en-US" smtClean="0"/>
+              <a:rPr lang="en-US"/>
               <a:t>Click to edit Master title style</a:t>
             </a:r>
-            <a:endParaRPr lang="en-US"/>
           </a:p>
         </p:txBody>
       </p:sp>
@@ -2503,7 +2500,7 @@
           <a:p>
             <a:pPr lvl="0"/>
             <a:r>
-              <a:rPr lang="en-US" smtClean="0"/>
+              <a:rPr lang="en-US"/>
               <a:t>Click to edit Master text styles</a:t>
             </a:r>
           </a:p>
@@ -2526,7 +2523,7 @@
           <a:p>
             <a:fld id="{5BCAD085-E8A6-8845-BD4E-CB4CCA059FC4}" type="datetimeFigureOut">
               <a:rPr lang="en-US" smtClean="0"/>
-              <a:t>1/27/13</a:t>
+              <a:t>9/30/2026</a:t>
             </a:fld>
             <a:endParaRPr lang="en-US"/>
           </a:p>
@@ -2635,10 +2632,9 @@
           <a:lstStyle/>
           <a:p>
             <a:r>
-              <a:rPr lang="en-US" smtClean="0"/>
+              <a:rPr lang="en-US"/>
               <a:t>Click to edit Master title style</a:t>
             </a:r>
-            <a:endParaRPr lang="en-US"/>
           </a:p>
         </p:txBody>
       </p:sp>
@@ -2669,38 +2665,37 @@
           <a:p>
             <a:pPr lvl="0"/>
             <a:r>
-              <a:rPr lang="en-US" smtClean="0"/>
+              <a:rPr lang="en-US"/>
               <a:t>Click to edit Master text styles</a:t>
             </a:r>
           </a:p>
           <a:p>
             <a:pPr lvl="1"/>
             <a:r>
-              <a:rPr lang="en-US" smtClean="0"/>
+              <a:rPr lang="en-US"/>
               <a:t>Second level</a:t>
             </a:r>
           </a:p>
           <a:p>
             <a:pPr lvl="2"/>
             <a:r>
-              <a:rPr lang="en-US" smtClean="0"/>
+              <a:rPr lang="en-US"/>
               <a:t>Third level</a:t>
             </a:r>
           </a:p>
           <a:p>
             <a:pPr lvl="3"/>
             <a:r>
-              <a:rPr lang="en-US" smtClean="0"/>
+              <a:rPr lang="en-US"/>
               <a:t>Fourth level</a:t>
             </a:r>
           </a:p>
           <a:p>
             <a:pPr lvl="4"/>
             <a:r>
-              <a:rPr lang="en-US" smtClean="0"/>
+              <a:rPr lang="en-US"/>
               <a:t>Fifth level</a:t>
             </a:r>
-            <a:endParaRPr lang="en-US"/>
           </a:p>
         </p:txBody>
       </p:sp>
@@ -2739,7 +2734,7 @@
           <a:p>
             <a:fld id="{5BCAD085-E8A6-8845-BD4E-CB4CCA059FC4}" type="datetimeFigureOut">
               <a:rPr lang="en-US" smtClean="0"/>
-              <a:t>1/27/13</a:t>
+              <a:t>9/30/2026</a:t>
             </a:fld>
             <a:endParaRPr lang="en-US"/>
           </a:p>
@@ -3098,7 +3093,7 @@
 </file>
 
 <file path=ppt/slides/slide1.xml><?xml version="1.0" encoding="utf-8"?>
-<p:sld xmlns:a="http://schemas.openxmlformats.org/drawingml/2006/main" xmlns:p="http://schemas.openxmlformats.org/presentationml/2006/main" xmlns:r="http://schemas.openxmlformats.org/officeDocument/2006/relationships">
+<p:sld xmlns:a="http://schemas.openxmlformats.org/drawingml/2006/main" xmlns:r="http://schemas.openxmlformats.org/officeDocument/2006/relationships" xmlns:p="http://schemas.openxmlformats.org/presentationml/2006/main">
   <p:cSld>
     <p:bg>
       <p:bgPr>
@@ -3114,7 +3109,14 @@
         <p:cNvGrpSpPr/>
         <p:nvPr/>
       </p:nvGrpSpPr>
-      <p:grpSpPr/>
+      <p:grpSpPr>
+        <a:xfrm>
+          <a:off x="0" y="0"/>
+          <a:ext cx="0" cy="0"/>
+          <a:chOff x="0" y="0"/>
+          <a:chExt cx="0" cy="0"/>
+        </a:xfrm>
+      </p:grpSpPr>
       <p:sp>
         <p:nvSpPr>
           <p:cNvPr id="2" name="TextBox 1"/>
@@ -3149,14 +3151,47 @@
               </a:spcAft>
             </a:pPr>
             <a:r>
-              <a:rPr sz="2700" b="1" i="0">
+              <a:rPr sz="2700" b="1" i="0" dirty="0">
                 <a:solidFill>
                   <a:srgbClr val="111111"/>
                 </a:solidFill>
                 <a:latin typeface="Arial"/>
               </a:rPr>
-              <a:t>Task-Oriented Deep Joint Source–Channel Coding</a:t>
-            </a:r>
+              <a:t>Task-Oriented </a:t>
+            </a:r>
+            <a:r>
+              <a:rPr sz="2700" b="1" i="0" dirty="0" err="1">
+                <a:solidFill>
+                  <a:srgbClr val="111111"/>
+                </a:solidFill>
+                <a:latin typeface="Arial"/>
+              </a:rPr>
+              <a:t>Deep</a:t>
+            </a:r>
+            <a:r>
+              <a:rPr lang="en-US" sz="2700" b="1" i="0" dirty="0" err="1">
+                <a:solidFill>
+                  <a:srgbClr val="111111"/>
+                </a:solidFill>
+                <a:latin typeface="Arial"/>
+              </a:rPr>
+              <a:t>JSCC</a:t>
+            </a:r>
+            <a:r>
+              <a:rPr lang="en-US" sz="2700" b="1" i="0" dirty="0">
+                <a:solidFill>
+                  <a:srgbClr val="111111"/>
+                </a:solidFill>
+                <a:latin typeface="Arial"/>
+              </a:rPr>
+              <a:t> Based Semantic Communication</a:t>
+            </a:r>
+            <a:endParaRPr sz="2700" b="1" i="0" dirty="0">
+              <a:solidFill>
+                <a:srgbClr val="111111"/>
+              </a:solidFill>
+              <a:latin typeface="Arial"/>
+            </a:endParaRPr>
           </a:p>
         </p:txBody>
       </p:sp>
@@ -3229,7 +3264,7 @@
               </a:spcAft>
             </a:pPr>
             <a:r>
-              <a:rPr sz="2000" b="0" i="1">
+              <a:rPr sz="2000" b="0" i="1" dirty="0">
                 <a:solidFill>
                   <a:srgbClr val="111111"/>
                 </a:solidFill>
@@ -3282,6 +3317,7 @@
           <a:lstStyle/>
           <a:p>
             <a:pPr algn="ctr"/>
+            <a:endParaRPr/>
           </a:p>
         </p:txBody>
       </p:sp>
@@ -3319,7 +3355,7 @@
               </a:spcAft>
             </a:pPr>
             <a:r>
-              <a:rPr sz="1400" b="1" i="0">
+              <a:rPr sz="1400" b="1" i="0" dirty="0">
                 <a:solidFill>
                   <a:srgbClr val="111111"/>
                 </a:solidFill>
@@ -3417,6 +3453,7 @@
           <a:lstStyle/>
           <a:p>
             <a:pPr algn="ctr"/>
+            <a:endParaRPr/>
           </a:p>
         </p:txBody>
       </p:sp>
@@ -3552,6 +3589,7 @@
           <a:lstStyle/>
           <a:p>
             <a:pPr algn="ctr"/>
+            <a:endParaRPr/>
           </a:p>
         </p:txBody>
       </p:sp>
@@ -3720,6 +3758,7 @@
           <a:lstStyle/>
           <a:p>
             <a:pPr algn="ctr"/>
+            <a:endParaRPr/>
           </a:p>
         </p:txBody>
       </p:sp>
@@ -3798,6 +3837,7 @@
           <a:lstStyle/>
           <a:p>
             <a:pPr algn="ctr"/>
+            <a:endParaRPr/>
           </a:p>
         </p:txBody>
       </p:sp>
@@ -3843,6 +3883,7 @@
           <a:lstStyle/>
           <a:p>
             <a:pPr algn="ctr"/>
+            <a:endParaRPr/>
           </a:p>
         </p:txBody>
       </p:sp>
@@ -4195,7 +4236,7 @@
 </file>
 
 <file path=ppt/slides/slide10.xml><?xml version="1.0" encoding="utf-8"?>
-<p:sld xmlns:a="http://schemas.openxmlformats.org/drawingml/2006/main" xmlns:p="http://schemas.openxmlformats.org/presentationml/2006/main" xmlns:r="http://schemas.openxmlformats.org/officeDocument/2006/relationships">
+<p:sld xmlns:a="http://schemas.openxmlformats.org/drawingml/2006/main" xmlns:r="http://schemas.openxmlformats.org/officeDocument/2006/relationships" xmlns:p="http://schemas.openxmlformats.org/presentationml/2006/main">
   <p:cSld>
     <p:bg>
       <p:bgPr>
@@ -4211,7 +4252,14 @@
         <p:cNvGrpSpPr/>
         <p:nvPr/>
       </p:nvGrpSpPr>
-      <p:grpSpPr/>
+      <p:grpSpPr>
+        <a:xfrm>
+          <a:off x="0" y="0"/>
+          <a:ext cx="0" cy="0"/>
+          <a:chOff x="0" y="0"/>
+          <a:chExt cx="0" cy="0"/>
+        </a:xfrm>
+      </p:grpSpPr>
       <p:sp>
         <p:nvSpPr>
           <p:cNvPr id="2" name="TextBox 1"/>
@@ -4880,7 +4928,7 @@
 </file>
 
 <file path=ppt/slides/slide11.xml><?xml version="1.0" encoding="utf-8"?>
-<p:sld xmlns:a="http://schemas.openxmlformats.org/drawingml/2006/main" xmlns:p="http://schemas.openxmlformats.org/presentationml/2006/main" xmlns:r="http://schemas.openxmlformats.org/officeDocument/2006/relationships">
+<p:sld xmlns:a="http://schemas.openxmlformats.org/drawingml/2006/main" xmlns:r="http://schemas.openxmlformats.org/officeDocument/2006/relationships" xmlns:p="http://schemas.openxmlformats.org/presentationml/2006/main">
   <p:cSld>
     <p:bg>
       <p:bgPr>
@@ -4896,7 +4944,14 @@
         <p:cNvGrpSpPr/>
         <p:nvPr/>
       </p:nvGrpSpPr>
-      <p:grpSpPr/>
+      <p:grpSpPr>
+        <a:xfrm>
+          <a:off x="0" y="0"/>
+          <a:ext cx="0" cy="0"/>
+          <a:chOff x="0" y="0"/>
+          <a:chExt cx="0" cy="0"/>
+        </a:xfrm>
+      </p:grpSpPr>
       <p:sp>
         <p:nvSpPr>
           <p:cNvPr id="2" name="TextBox 1"/>
@@ -5088,6 +5143,7 @@
           <a:lstStyle/>
           <a:p>
             <a:pPr algn="ctr"/>
+            <a:endParaRPr/>
           </a:p>
         </p:txBody>
       </p:sp>
@@ -5403,6 +5459,7 @@
           <a:lstStyle/>
           <a:p>
             <a:pPr algn="ctr"/>
+            <a:endParaRPr/>
           </a:p>
         </p:txBody>
       </p:sp>
@@ -5718,6 +5775,7 @@
           <a:lstStyle/>
           <a:p>
             <a:pPr algn="ctr"/>
+            <a:endParaRPr/>
           </a:p>
         </p:txBody>
       </p:sp>
@@ -6345,7 +6403,7 @@
 </file>
 
 <file path=ppt/slides/slide12.xml><?xml version="1.0" encoding="utf-8"?>
-<p:sld xmlns:a="http://schemas.openxmlformats.org/drawingml/2006/main" xmlns:p="http://schemas.openxmlformats.org/presentationml/2006/main" xmlns:r="http://schemas.openxmlformats.org/officeDocument/2006/relationships">
+<p:sld xmlns:a="http://schemas.openxmlformats.org/drawingml/2006/main" xmlns:r="http://schemas.openxmlformats.org/officeDocument/2006/relationships" xmlns:p="http://schemas.openxmlformats.org/presentationml/2006/main">
   <p:cSld>
     <p:bg>
       <p:bgPr>
@@ -6361,7 +6419,14 @@
         <p:cNvGrpSpPr/>
         <p:nvPr/>
       </p:nvGrpSpPr>
-      <p:grpSpPr/>
+      <p:grpSpPr>
+        <a:xfrm>
+          <a:off x="0" y="0"/>
+          <a:ext cx="0" cy="0"/>
+          <a:chOff x="0" y="0"/>
+          <a:chExt cx="0" cy="0"/>
+        </a:xfrm>
+      </p:grpSpPr>
       <p:sp>
         <p:nvSpPr>
           <p:cNvPr id="2" name="TextBox 1"/>
@@ -6905,7 +6970,7 @@
 </file>
 
 <file path=ppt/slides/slide13.xml><?xml version="1.0" encoding="utf-8"?>
-<p:sld xmlns:a="http://schemas.openxmlformats.org/drawingml/2006/main" xmlns:p="http://schemas.openxmlformats.org/presentationml/2006/main" xmlns:r="http://schemas.openxmlformats.org/officeDocument/2006/relationships">
+<p:sld xmlns:a="http://schemas.openxmlformats.org/drawingml/2006/main" xmlns:r="http://schemas.openxmlformats.org/officeDocument/2006/relationships" xmlns:p="http://schemas.openxmlformats.org/presentationml/2006/main">
   <p:cSld>
     <p:bg>
       <p:bgPr>
@@ -6921,7 +6986,14 @@
         <p:cNvGrpSpPr/>
         <p:nvPr/>
       </p:nvGrpSpPr>
-      <p:grpSpPr/>
+      <p:grpSpPr>
+        <a:xfrm>
+          <a:off x="0" y="0"/>
+          <a:ext cx="0" cy="0"/>
+          <a:chOff x="0" y="0"/>
+          <a:chExt cx="0" cy="0"/>
+        </a:xfrm>
+      </p:grpSpPr>
       <p:sp>
         <p:nvSpPr>
           <p:cNvPr id="2" name="TextBox 1"/>
@@ -7158,6 +7230,7 @@
           <a:lstStyle/>
           <a:p>
             <a:pPr algn="ctr"/>
+            <a:endParaRPr/>
           </a:p>
         </p:txBody>
       </p:sp>
@@ -7383,6 +7456,7 @@
           <a:lstStyle/>
           <a:p>
             <a:pPr algn="ctr"/>
+            <a:endParaRPr/>
           </a:p>
         </p:txBody>
       </p:sp>
@@ -7608,6 +7682,7 @@
           <a:lstStyle/>
           <a:p>
             <a:pPr algn="ctr"/>
+            <a:endParaRPr/>
           </a:p>
         </p:txBody>
       </p:sp>
@@ -8075,7 +8150,7 @@
 </file>
 
 <file path=ppt/slides/slide14.xml><?xml version="1.0" encoding="utf-8"?>
-<p:sld xmlns:a="http://schemas.openxmlformats.org/drawingml/2006/main" xmlns:p="http://schemas.openxmlformats.org/presentationml/2006/main" xmlns:r="http://schemas.openxmlformats.org/officeDocument/2006/relationships">
+<p:sld xmlns:a="http://schemas.openxmlformats.org/drawingml/2006/main" xmlns:r="http://schemas.openxmlformats.org/officeDocument/2006/relationships" xmlns:p="http://schemas.openxmlformats.org/presentationml/2006/main">
   <p:cSld>
     <p:bg>
       <p:bgPr>
@@ -8091,7 +8166,14 @@
         <p:cNvGrpSpPr/>
         <p:nvPr/>
       </p:nvGrpSpPr>
-      <p:grpSpPr/>
+      <p:grpSpPr>
+        <a:xfrm>
+          <a:off x="0" y="0"/>
+          <a:ext cx="0" cy="0"/>
+          <a:chOff x="0" y="0"/>
+          <a:chExt cx="0" cy="0"/>
+        </a:xfrm>
+      </p:grpSpPr>
       <p:sp>
         <p:nvSpPr>
           <p:cNvPr id="2" name="TextBox 1"/>
@@ -8885,7 +8967,7 @@
 </file>
 
 <file path=ppt/slides/slide15.xml><?xml version="1.0" encoding="utf-8"?>
-<p:sld xmlns:a="http://schemas.openxmlformats.org/drawingml/2006/main" xmlns:p="http://schemas.openxmlformats.org/presentationml/2006/main" xmlns:r="http://schemas.openxmlformats.org/officeDocument/2006/relationships">
+<p:sld xmlns:a="http://schemas.openxmlformats.org/drawingml/2006/main" xmlns:r="http://schemas.openxmlformats.org/officeDocument/2006/relationships" xmlns:p="http://schemas.openxmlformats.org/presentationml/2006/main">
   <p:cSld>
     <p:bg>
       <p:bgPr>
@@ -8901,7 +8983,14 @@
         <p:cNvGrpSpPr/>
         <p:nvPr/>
       </p:nvGrpSpPr>
-      <p:grpSpPr/>
+      <p:grpSpPr>
+        <a:xfrm>
+          <a:off x="0" y="0"/>
+          <a:ext cx="0" cy="0"/>
+          <a:chOff x="0" y="0"/>
+          <a:chExt cx="0" cy="0"/>
+        </a:xfrm>
+      </p:grpSpPr>
       <p:sp>
         <p:nvSpPr>
           <p:cNvPr id="2" name="TextBox 1"/>
@@ -9114,6 +9203,7 @@
           <a:lstStyle/>
           <a:p>
             <a:pPr algn="ctr"/>
+            <a:endParaRPr/>
           </a:p>
         </p:txBody>
       </p:sp>
@@ -9474,6 +9564,7 @@
           <a:lstStyle/>
           <a:p>
             <a:pPr algn="ctr"/>
+            <a:endParaRPr/>
           </a:p>
         </p:txBody>
       </p:sp>
@@ -9834,6 +9925,7 @@
           <a:lstStyle/>
           <a:p>
             <a:pPr algn="ctr"/>
+            <a:endParaRPr/>
           </a:p>
         </p:txBody>
       </p:sp>
@@ -10194,6 +10286,7 @@
           <a:lstStyle/>
           <a:p>
             <a:pPr algn="ctr"/>
+            <a:endParaRPr/>
           </a:p>
         </p:txBody>
       </p:sp>
@@ -10554,6 +10647,7 @@
           <a:lstStyle/>
           <a:p>
             <a:pPr algn="ctr"/>
+            <a:endParaRPr/>
           </a:p>
         </p:txBody>
       </p:sp>
@@ -10914,6 +11008,7 @@
           <a:lstStyle/>
           <a:p>
             <a:pPr algn="ctr"/>
+            <a:endParaRPr/>
           </a:p>
         </p:txBody>
       </p:sp>
@@ -11529,6 +11624,7 @@
           <a:lstStyle/>
           <a:p>
             <a:pPr algn="ctr"/>
+            <a:endParaRPr/>
           </a:p>
         </p:txBody>
       </p:sp>
@@ -11889,6 +11985,7 @@
           <a:lstStyle/>
           <a:p>
             <a:pPr algn="ctr"/>
+            <a:endParaRPr/>
           </a:p>
         </p:txBody>
       </p:sp>
@@ -12249,6 +12346,7 @@
           <a:lstStyle/>
           <a:p>
             <a:pPr algn="ctr"/>
+            <a:endParaRPr/>
           </a:p>
         </p:txBody>
       </p:sp>
@@ -13171,7 +13269,7 @@
 </file>
 
 <file path=ppt/slides/slide16.xml><?xml version="1.0" encoding="utf-8"?>
-<p:sld xmlns:a="http://schemas.openxmlformats.org/drawingml/2006/main" xmlns:p="http://schemas.openxmlformats.org/presentationml/2006/main" xmlns:r="http://schemas.openxmlformats.org/officeDocument/2006/relationships">
+<p:sld xmlns:a="http://schemas.openxmlformats.org/drawingml/2006/main" xmlns:r="http://schemas.openxmlformats.org/officeDocument/2006/relationships" xmlns:p="http://schemas.openxmlformats.org/presentationml/2006/main">
   <p:cSld>
     <p:bg>
       <p:bgPr>
@@ -13187,7 +13285,14 @@
         <p:cNvGrpSpPr/>
         <p:nvPr/>
       </p:nvGrpSpPr>
-      <p:grpSpPr/>
+      <p:grpSpPr>
+        <a:xfrm>
+          <a:off x="0" y="0"/>
+          <a:ext cx="0" cy="0"/>
+          <a:chOff x="0" y="0"/>
+          <a:chExt cx="0" cy="0"/>
+        </a:xfrm>
+      </p:grpSpPr>
       <p:sp>
         <p:nvSpPr>
           <p:cNvPr id="2" name="TextBox 1"/>
@@ -14117,7 +14222,7 @@
 </file>
 
 <file path=ppt/slides/slide17.xml><?xml version="1.0" encoding="utf-8"?>
-<p:sld xmlns:a="http://schemas.openxmlformats.org/drawingml/2006/main" xmlns:p="http://schemas.openxmlformats.org/presentationml/2006/main" xmlns:r="http://schemas.openxmlformats.org/officeDocument/2006/relationships">
+<p:sld xmlns:a="http://schemas.openxmlformats.org/drawingml/2006/main" xmlns:r="http://schemas.openxmlformats.org/officeDocument/2006/relationships" xmlns:p="http://schemas.openxmlformats.org/presentationml/2006/main">
   <p:cSld>
     <p:bg>
       <p:bgPr>
@@ -14133,7 +14238,14 @@
         <p:cNvGrpSpPr/>
         <p:nvPr/>
       </p:nvGrpSpPr>
-      <p:grpSpPr/>
+      <p:grpSpPr>
+        <a:xfrm>
+          <a:off x="0" y="0"/>
+          <a:ext cx="0" cy="0"/>
+          <a:chOff x="0" y="0"/>
+          <a:chExt cx="0" cy="0"/>
+        </a:xfrm>
+      </p:grpSpPr>
       <p:sp>
         <p:nvSpPr>
           <p:cNvPr id="2" name="TextBox 1"/>
@@ -14301,6 +14413,7 @@
           <a:lstStyle/>
           <a:p>
             <a:pPr algn="ctr"/>
+            <a:endParaRPr/>
           </a:p>
         </p:txBody>
       </p:sp>
@@ -14516,6 +14629,7 @@
           <a:lstStyle/>
           <a:p>
             <a:pPr algn="ctr"/>
+            <a:endParaRPr/>
           </a:p>
         </p:txBody>
       </p:sp>
@@ -14731,6 +14845,7 @@
           <a:lstStyle/>
           <a:p>
             <a:pPr algn="ctr"/>
+            <a:endParaRPr/>
           </a:p>
         </p:txBody>
       </p:sp>
@@ -14946,6 +15061,7 @@
           <a:lstStyle/>
           <a:p>
             <a:pPr algn="ctr"/>
+            <a:endParaRPr/>
           </a:p>
         </p:txBody>
       </p:sp>
@@ -15378,7 +15494,7 @@
 </file>
 
 <file path=ppt/slides/slide18.xml><?xml version="1.0" encoding="utf-8"?>
-<p:sld xmlns:a="http://schemas.openxmlformats.org/drawingml/2006/main" xmlns:p="http://schemas.openxmlformats.org/presentationml/2006/main" xmlns:r="http://schemas.openxmlformats.org/officeDocument/2006/relationships">
+<p:sld xmlns:a="http://schemas.openxmlformats.org/drawingml/2006/main" xmlns:r="http://schemas.openxmlformats.org/officeDocument/2006/relationships" xmlns:p="http://schemas.openxmlformats.org/presentationml/2006/main">
   <p:cSld>
     <p:bg>
       <p:bgPr>
@@ -15394,7 +15510,14 @@
         <p:cNvGrpSpPr/>
         <p:nvPr/>
       </p:nvGrpSpPr>
-      <p:grpSpPr/>
+      <p:grpSpPr>
+        <a:xfrm>
+          <a:off x="0" y="0"/>
+          <a:ext cx="0" cy="0"/>
+          <a:chOff x="0" y="0"/>
+          <a:chExt cx="0" cy="0"/>
+        </a:xfrm>
+      </p:grpSpPr>
       <p:sp>
         <p:nvSpPr>
           <p:cNvPr id="2" name="TextBox 1"/>
@@ -15517,6 +15640,7 @@
           <a:lstStyle/>
           <a:p>
             <a:pPr algn="ctr"/>
+            <a:endParaRPr/>
           </a:p>
         </p:txBody>
       </p:sp>
@@ -15732,6 +15856,7 @@
           <a:lstStyle/>
           <a:p>
             <a:pPr algn="ctr"/>
+            <a:endParaRPr/>
           </a:p>
         </p:txBody>
       </p:sp>
@@ -16659,7 +16784,7 @@
 </file>
 
 <file path=ppt/slides/slide19.xml><?xml version="1.0" encoding="utf-8"?>
-<p:sld xmlns:a="http://schemas.openxmlformats.org/drawingml/2006/main" xmlns:p="http://schemas.openxmlformats.org/presentationml/2006/main" xmlns:r="http://schemas.openxmlformats.org/officeDocument/2006/relationships">
+<p:sld xmlns:a="http://schemas.openxmlformats.org/drawingml/2006/main" xmlns:r="http://schemas.openxmlformats.org/officeDocument/2006/relationships" xmlns:p="http://schemas.openxmlformats.org/presentationml/2006/main">
   <p:cSld>
     <p:bg>
       <p:bgPr>
@@ -16675,7 +16800,14 @@
         <p:cNvGrpSpPr/>
         <p:nvPr/>
       </p:nvGrpSpPr>
-      <p:grpSpPr/>
+      <p:grpSpPr>
+        <a:xfrm>
+          <a:off x="0" y="0"/>
+          <a:ext cx="0" cy="0"/>
+          <a:chOff x="0" y="0"/>
+          <a:chExt cx="0" cy="0"/>
+        </a:xfrm>
+      </p:grpSpPr>
       <p:sp>
         <p:nvSpPr>
           <p:cNvPr id="2" name="TextBox 1"/>
@@ -18735,7 +18867,7 @@
 </file>
 
 <file path=ppt/slides/slide2.xml><?xml version="1.0" encoding="utf-8"?>
-<p:sld xmlns:a="http://schemas.openxmlformats.org/drawingml/2006/main" xmlns:p="http://schemas.openxmlformats.org/presentationml/2006/main" xmlns:r="http://schemas.openxmlformats.org/officeDocument/2006/relationships">
+<p:sld xmlns:a="http://schemas.openxmlformats.org/drawingml/2006/main" xmlns:r="http://schemas.openxmlformats.org/officeDocument/2006/relationships" xmlns:p="http://schemas.openxmlformats.org/presentationml/2006/main">
   <p:cSld>
     <p:bg>
       <p:bgPr>
@@ -18751,7 +18883,14 @@
         <p:cNvGrpSpPr/>
         <p:nvPr/>
       </p:nvGrpSpPr>
-      <p:grpSpPr/>
+      <p:grpSpPr>
+        <a:xfrm>
+          <a:off x="0" y="0"/>
+          <a:ext cx="0" cy="0"/>
+          <a:chOff x="0" y="0"/>
+          <a:chExt cx="0" cy="0"/>
+        </a:xfrm>
+      </p:grpSpPr>
       <p:sp>
         <p:nvSpPr>
           <p:cNvPr id="2" name="TextBox 1"/>
@@ -18786,14 +18925,38 @@
               </a:spcAft>
             </a:pPr>
             <a:r>
-              <a:rPr sz="2700" b="1" i="0">
+              <a:rPr lang="en-US" sz="2700" b="1" dirty="0">
                 <a:solidFill>
                   <a:srgbClr val="111111"/>
                 </a:solidFill>
                 <a:latin typeface="Arial"/>
               </a:rPr>
-              <a:t>What has changed since the first review</a:t>
-            </a:r>
+              <a:t>Progress </a:t>
+            </a:r>
+            <a:r>
+              <a:rPr lang="en-US" sz="2700" b="1" dirty="0" err="1">
+                <a:solidFill>
+                  <a:srgbClr val="111111"/>
+                </a:solidFill>
+                <a:latin typeface="Arial"/>
+              </a:rPr>
+              <a:t>upto</a:t>
+            </a:r>
+            <a:r>
+              <a:rPr lang="en-US" sz="2700" b="1" dirty="0">
+                <a:solidFill>
+                  <a:srgbClr val="111111"/>
+                </a:solidFill>
+                <a:latin typeface="Arial"/>
+              </a:rPr>
+              <a:t> Sep. 30th</a:t>
+            </a:r>
+            <a:endParaRPr sz="2700" b="1" i="0" dirty="0">
+              <a:solidFill>
+                <a:srgbClr val="111111"/>
+              </a:solidFill>
+              <a:latin typeface="Arial"/>
+            </a:endParaRPr>
           </a:p>
         </p:txBody>
       </p:sp>
@@ -18866,14 +19029,20 @@
               </a:spcAft>
             </a:pPr>
             <a:r>
-              <a:rPr sz="1400" b="0" i="0">
+              <a:rPr lang="en-US" sz="1400" b="0" i="0" dirty="0">
                 <a:solidFill>
                   <a:srgbClr val="555555"/>
                 </a:solidFill>
                 <a:latin typeface="Arial"/>
               </a:rPr>
-              <a:t>In August the digital system was working. The learned models are trained now.</a:t>
-            </a:r>
+              <a:t>All learned models are trained now.</a:t>
+            </a:r>
+            <a:endParaRPr sz="1400" b="0" i="0" dirty="0">
+              <a:solidFill>
+                <a:srgbClr val="555555"/>
+              </a:solidFill>
+              <a:latin typeface="Arial"/>
+            </a:endParaRPr>
           </a:p>
         </p:txBody>
       </p:sp>
@@ -18956,7 +19125,7 @@
               </a:spcAft>
             </a:pPr>
             <a:r>
-              <a:rPr sz="1100" b="0" i="0">
+              <a:rPr sz="1100" b="0" i="0" dirty="0">
                 <a:solidFill>
                   <a:srgbClr val="555555"/>
                 </a:solidFill>
@@ -19081,7 +19250,7 @@
               </a:spcAft>
             </a:pPr>
             <a:r>
-              <a:rPr sz="1100" b="0" i="0">
+              <a:rPr sz="1100" b="0" i="0" dirty="0">
                 <a:solidFill>
                   <a:srgbClr val="555555"/>
                 </a:solidFill>
@@ -19206,7 +19375,7 @@
               </a:spcAft>
             </a:pPr>
             <a:r>
-              <a:rPr sz="1100" b="0" i="0">
+              <a:rPr sz="1100" b="0" i="0" dirty="0">
                 <a:solidFill>
                   <a:srgbClr val="555555"/>
                 </a:solidFill>
@@ -19331,7 +19500,7 @@
               </a:spcAft>
             </a:pPr>
             <a:r>
-              <a:rPr sz="1100" b="0" i="0">
+              <a:rPr sz="1100" b="0" i="0" dirty="0">
                 <a:solidFill>
                   <a:srgbClr val="555555"/>
                 </a:solidFill>
@@ -19456,14 +19625,29 @@
               </a:spcAft>
             </a:pPr>
             <a:r>
-              <a:rPr sz="1100" b="0" i="0">
+              <a:rPr sz="1100" b="0" i="0" dirty="0">
                 <a:solidFill>
                   <a:srgbClr val="555555"/>
                 </a:solidFill>
                 <a:latin typeface="Arial"/>
               </a:rPr>
-              <a:t>Decided it on held-back pictures before seeing the answer: the two lines cross between −5 and −4 dB.</a:t>
-            </a:r>
+              <a:t>Decided it on held-back pictures before seeing the answer: the two lines cross between −5 and −4 </a:t>
+            </a:r>
+            <a:r>
+              <a:rPr sz="1100" b="0" i="0" dirty="0" err="1">
+                <a:solidFill>
+                  <a:srgbClr val="555555"/>
+                </a:solidFill>
+                <a:latin typeface="Arial"/>
+              </a:rPr>
+              <a:t>dB.</a:t>
+            </a:r>
+            <a:endParaRPr sz="1100" b="0" i="0" dirty="0">
+              <a:solidFill>
+                <a:srgbClr val="555555"/>
+              </a:solidFill>
+              <a:latin typeface="Arial"/>
+            </a:endParaRPr>
           </a:p>
         </p:txBody>
       </p:sp>
@@ -19581,7 +19765,7 @@
               </a:spcAft>
             </a:pPr>
             <a:r>
-              <a:rPr sz="1100" b="0" i="0">
+              <a:rPr sz="1100" b="0" i="0" dirty="0">
                 <a:solidFill>
                   <a:srgbClr val="555555"/>
                 </a:solidFill>
@@ -20021,7 +20205,7 @@
 </file>
 
 <file path=ppt/slides/slide20.xml><?xml version="1.0" encoding="utf-8"?>
-<p:sld xmlns:a="http://schemas.openxmlformats.org/drawingml/2006/main" xmlns:p="http://schemas.openxmlformats.org/presentationml/2006/main" xmlns:r="http://schemas.openxmlformats.org/officeDocument/2006/relationships">
+<p:sld xmlns:a="http://schemas.openxmlformats.org/drawingml/2006/main" xmlns:r="http://schemas.openxmlformats.org/officeDocument/2006/relationships" xmlns:p="http://schemas.openxmlformats.org/presentationml/2006/main">
   <p:cSld>
     <p:bg>
       <p:bgPr>
@@ -20037,7 +20221,14 @@
         <p:cNvGrpSpPr/>
         <p:nvPr/>
       </p:nvGrpSpPr>
-      <p:grpSpPr/>
+      <p:grpSpPr>
+        <a:xfrm>
+          <a:off x="0" y="0"/>
+          <a:ext cx="0" cy="0"/>
+          <a:chOff x="0" y="0"/>
+          <a:chExt cx="0" cy="0"/>
+        </a:xfrm>
+      </p:grpSpPr>
       <p:sp>
         <p:nvSpPr>
           <p:cNvPr id="2" name="TextBox 1"/>
@@ -20160,6 +20351,7 @@
           <a:lstStyle/>
           <a:p>
             <a:pPr algn="ctr"/>
+            <a:endParaRPr/>
           </a:p>
         </p:txBody>
       </p:sp>
@@ -20852,7 +21044,7 @@
 </file>
 
 <file path=ppt/slides/slide3.xml><?xml version="1.0" encoding="utf-8"?>
-<p:sld xmlns:a="http://schemas.openxmlformats.org/drawingml/2006/main" xmlns:p="http://schemas.openxmlformats.org/presentationml/2006/main" xmlns:r="http://schemas.openxmlformats.org/officeDocument/2006/relationships">
+<p:sld xmlns:a="http://schemas.openxmlformats.org/drawingml/2006/main" xmlns:r="http://schemas.openxmlformats.org/officeDocument/2006/relationships" xmlns:p="http://schemas.openxmlformats.org/presentationml/2006/main">
   <p:cSld>
     <p:bg>
       <p:bgPr>
@@ -20868,7 +21060,14 @@
         <p:cNvGrpSpPr/>
         <p:nvPr/>
       </p:nvGrpSpPr>
-      <p:grpSpPr/>
+      <p:grpSpPr>
+        <a:xfrm>
+          <a:off x="0" y="0"/>
+          <a:ext cx="0" cy="0"/>
+          <a:chOff x="0" y="0"/>
+          <a:chExt cx="0" cy="0"/>
+        </a:xfrm>
+      </p:grpSpPr>
       <p:sp>
         <p:nvSpPr>
           <p:cNvPr id="2" name="TextBox 1"/>
@@ -20903,14 +21102,29 @@
               </a:spcAft>
             </a:pPr>
             <a:r>
-              <a:rPr sz="2700" b="1" i="0">
+              <a:rPr sz="2700" b="1" i="0" dirty="0">
                 <a:solidFill>
                   <a:srgbClr val="111111"/>
                 </a:solidFill>
                 <a:latin typeface="Arial"/>
               </a:rPr>
-              <a:t>Objectives, stated as completion criteria</a:t>
-            </a:r>
+              <a:t>Objective</a:t>
+            </a:r>
+            <a:r>
+              <a:rPr lang="en-US" sz="2700" b="1" dirty="0">
+                <a:solidFill>
+                  <a:srgbClr val="111111"/>
+                </a:solidFill>
+                <a:latin typeface="Arial"/>
+              </a:rPr>
+              <a:t>s</a:t>
+            </a:r>
+            <a:endParaRPr sz="2700" b="1" i="0" dirty="0">
+              <a:solidFill>
+                <a:srgbClr val="111111"/>
+              </a:solidFill>
+              <a:latin typeface="Arial"/>
+            </a:endParaRPr>
           </a:p>
         </p:txBody>
       </p:sp>
@@ -20951,14 +21165,14 @@
       </p:cxnSp>
       <p:sp>
         <p:nvSpPr>
-          <p:cNvPr id="4" name="TextBox 3"/>
-          <p:cNvSpPr txBox="1"/>
-          <p:nvPr/>
-        </p:nvSpPr>
-        <p:spPr>
-          <a:xfrm>
-            <a:off x="566928" y="1225296"/>
-            <a:ext cx="11018520" cy="310896"/>
+          <p:cNvPr id="5" name="TextBox 4"/>
+          <p:cNvSpPr txBox="1"/>
+          <p:nvPr/>
+        </p:nvSpPr>
+        <p:spPr>
+          <a:xfrm>
+            <a:off x="2834640" y="1458468"/>
+            <a:ext cx="6309360" cy="256032"/>
           </a:xfrm>
           <a:prstGeom prst="rect">
             <a:avLst/>
@@ -20971,39 +21185,39 @@
           </a:bodyPr>
           <a:lstStyle/>
           <a:p>
-            <a:pPr algn="ctr">
-              <a:lnSpc>
-                <a:spcPct val="100000"/>
-              </a:lnSpc>
-              <a:spcBef>
-                <a:spcPts val="0"/>
-              </a:spcBef>
-              <a:spcAft>
-                <a:spcPts val="0"/>
-              </a:spcAft>
-            </a:pPr>
-            <a:r>
-              <a:rPr sz="1250" b="0" i="0">
-                <a:solidFill>
-                  <a:srgbClr val="555555"/>
-                </a:solidFill>
-                <a:latin typeface="Arial"/>
-              </a:rPr>
-              <a:t>Five things we set out to build. Each one is checkable.</a:t>
-            </a:r>
-          </a:p>
-        </p:txBody>
-      </p:sp>
-      <p:sp>
-        <p:nvSpPr>
-          <p:cNvPr id="5" name="TextBox 4"/>
-          <p:cNvSpPr txBox="1"/>
-          <p:nvPr/>
-        </p:nvSpPr>
-        <p:spPr>
-          <a:xfrm>
-            <a:off x="658368" y="1700784"/>
-            <a:ext cx="6309360" cy="256032"/>
+            <a:pPr algn="l">
+              <a:lnSpc>
+                <a:spcPct val="100000"/>
+              </a:lnSpc>
+              <a:spcBef>
+                <a:spcPts val="0"/>
+              </a:spcBef>
+              <a:spcAft>
+                <a:spcPts val="0"/>
+              </a:spcAft>
+            </a:pPr>
+            <a:r>
+              <a:rPr sz="1300" b="1" i="0">
+                <a:solidFill>
+                  <a:srgbClr val="111111"/>
+                </a:solidFill>
+                <a:latin typeface="Arial"/>
+              </a:rPr>
+              <a:t>What we set out to do</a:t>
+            </a:r>
+          </a:p>
+        </p:txBody>
+      </p:sp>
+      <p:sp>
+        <p:nvSpPr>
+          <p:cNvPr id="6" name="TextBox 5"/>
+          <p:cNvSpPr txBox="1"/>
+          <p:nvPr/>
+        </p:nvSpPr>
+        <p:spPr>
+          <a:xfrm>
+            <a:off x="2834640" y="1860804"/>
+            <a:ext cx="2103120" cy="274320"/>
           </a:xfrm>
           <a:prstGeom prst="rect">
             <a:avLst/>
@@ -21028,27 +21242,27 @@
               </a:spcAft>
             </a:pPr>
             <a:r>
-              <a:rPr sz="1300" b="1" i="0">
+              <a:rPr sz="1200" b="1" i="0">
                 <a:solidFill>
                   <a:srgbClr val="111111"/>
                 </a:solidFill>
                 <a:latin typeface="Arial"/>
               </a:rPr>
-              <a:t>What we set out to do</a:t>
-            </a:r>
-          </a:p>
-        </p:txBody>
-      </p:sp>
-      <p:sp>
-        <p:nvSpPr>
-          <p:cNvPr id="6" name="TextBox 5"/>
-          <p:cNvSpPr txBox="1"/>
-          <p:nvPr/>
-        </p:nvSpPr>
-        <p:spPr>
-          <a:xfrm>
-            <a:off x="658368" y="2103120"/>
-            <a:ext cx="2103120" cy="274320"/>
+              <a:t>1.  Build it</a:t>
+            </a:r>
+          </a:p>
+        </p:txBody>
+      </p:sp>
+      <p:sp>
+        <p:nvSpPr>
+          <p:cNvPr id="7" name="TextBox 6"/>
+          <p:cNvSpPr txBox="1"/>
+          <p:nvPr/>
+        </p:nvSpPr>
+        <p:spPr>
+          <a:xfrm>
+            <a:off x="5010912" y="1842515"/>
+            <a:ext cx="4133087" cy="603504"/>
           </a:xfrm>
           <a:prstGeom prst="rect">
             <a:avLst/>
@@ -21073,52 +21287,7 @@
               </a:spcAft>
             </a:pPr>
             <a:r>
-              <a:rPr sz="1200" b="1" i="0">
-                <a:solidFill>
-                  <a:srgbClr val="111111"/>
-                </a:solidFill>
-                <a:latin typeface="Arial"/>
-              </a:rPr>
-              <a:t>1.  Build it</a:t>
-            </a:r>
-          </a:p>
-        </p:txBody>
-      </p:sp>
-      <p:sp>
-        <p:nvSpPr>
-          <p:cNvPr id="7" name="TextBox 6"/>
-          <p:cNvSpPr txBox="1"/>
-          <p:nvPr/>
-        </p:nvSpPr>
-        <p:spPr>
-          <a:xfrm>
-            <a:off x="2834640" y="2084831"/>
-            <a:ext cx="4133087" cy="603504"/>
-          </a:xfrm>
-          <a:prstGeom prst="rect">
-            <a:avLst/>
-          </a:prstGeom>
-          <a:noFill/>
-        </p:spPr>
-        <p:txBody>
-          <a:bodyPr wrap="square" lIns="45720" rIns="45720" anchor="t">
-            <a:spAutoFit/>
-          </a:bodyPr>
-          <a:lstStyle/>
-          <a:p>
-            <a:pPr algn="l">
-              <a:lnSpc>
-                <a:spcPct val="100000"/>
-              </a:lnSpc>
-              <a:spcBef>
-                <a:spcPts val="0"/>
-              </a:spcBef>
-              <a:spcAft>
-                <a:spcPts val="0"/>
-              </a:spcAft>
-            </a:pPr>
-            <a:r>
-              <a:rPr sz="1100" b="0" i="0">
+              <a:rPr sz="1100" b="0" i="0" dirty="0">
                 <a:solidFill>
                   <a:srgbClr val="555555"/>
                 </a:solidFill>
@@ -21137,7 +21306,7 @@
         </p:nvCxnSpPr>
         <p:spPr>
           <a:xfrm>
-            <a:off x="658368" y="2670048"/>
+            <a:off x="2834640" y="2427732"/>
             <a:ext cx="6309360" cy="0"/>
           </a:xfrm>
           <a:prstGeom prst="line">
@@ -21172,7 +21341,7 @@
         </p:nvSpPr>
         <p:spPr>
           <a:xfrm>
-            <a:off x="658368" y="2816352"/>
+            <a:off x="2834640" y="2574036"/>
             <a:ext cx="2103120" cy="274320"/>
           </a:xfrm>
           <a:prstGeom prst="rect">
@@ -21217,7 +21386,7 @@
         </p:nvSpPr>
         <p:spPr>
           <a:xfrm>
-            <a:off x="2834640" y="2798064"/>
+            <a:off x="5010912" y="2555748"/>
             <a:ext cx="4133087" cy="603504"/>
           </a:xfrm>
           <a:prstGeom prst="rect">
@@ -21262,7 +21431,7 @@
         </p:nvCxnSpPr>
         <p:spPr>
           <a:xfrm>
-            <a:off x="658368" y="3383280"/>
+            <a:off x="2834640" y="3140964"/>
             <a:ext cx="6309360" cy="0"/>
           </a:xfrm>
           <a:prstGeom prst="line">
@@ -21297,7 +21466,7 @@
         </p:nvSpPr>
         <p:spPr>
           <a:xfrm>
-            <a:off x="658368" y="3529584"/>
+            <a:off x="2834640" y="3287268"/>
             <a:ext cx="2103120" cy="274320"/>
           </a:xfrm>
           <a:prstGeom prst="rect">
@@ -21342,7 +21511,7 @@
         </p:nvSpPr>
         <p:spPr>
           <a:xfrm>
-            <a:off x="2834640" y="3511296"/>
+            <a:off x="5010912" y="3268980"/>
             <a:ext cx="4133087" cy="603504"/>
           </a:xfrm>
           <a:prstGeom prst="rect">
@@ -21368,7 +21537,7 @@
               </a:spcAft>
             </a:pPr>
             <a:r>
-              <a:rPr sz="1100" b="0" i="0">
+              <a:rPr sz="1100" b="0" i="0" dirty="0">
                 <a:solidFill>
                   <a:srgbClr val="555555"/>
                 </a:solidFill>
@@ -21387,7 +21556,7 @@
         </p:nvCxnSpPr>
         <p:spPr>
           <a:xfrm>
-            <a:off x="658368" y="4096511"/>
+            <a:off x="2834640" y="3854195"/>
             <a:ext cx="6309360" cy="0"/>
           </a:xfrm>
           <a:prstGeom prst="line">
@@ -21422,7 +21591,7 @@
         </p:nvSpPr>
         <p:spPr>
           <a:xfrm>
-            <a:off x="658368" y="4242816"/>
+            <a:off x="2834640" y="4000500"/>
             <a:ext cx="2103120" cy="274320"/>
           </a:xfrm>
           <a:prstGeom prst="rect">
@@ -21467,7 +21636,7 @@
         </p:nvSpPr>
         <p:spPr>
           <a:xfrm>
-            <a:off x="2834640" y="4224528"/>
+            <a:off x="5010912" y="3982212"/>
             <a:ext cx="4133087" cy="603504"/>
           </a:xfrm>
           <a:prstGeom prst="rect">
@@ -21512,7 +21681,7 @@
         </p:nvCxnSpPr>
         <p:spPr>
           <a:xfrm>
-            <a:off x="658368" y="4809744"/>
+            <a:off x="2834640" y="4567428"/>
             <a:ext cx="6309360" cy="0"/>
           </a:xfrm>
           <a:prstGeom prst="line">
@@ -21547,7 +21716,7 @@
         </p:nvSpPr>
         <p:spPr>
           <a:xfrm>
-            <a:off x="658368" y="4956048"/>
+            <a:off x="2834640" y="4713732"/>
             <a:ext cx="2103120" cy="274320"/>
           </a:xfrm>
           <a:prstGeom prst="rect">
@@ -21592,7 +21761,7 @@
         </p:nvSpPr>
         <p:spPr>
           <a:xfrm>
-            <a:off x="2834640" y="4937760"/>
+            <a:off x="5010912" y="4695444"/>
             <a:ext cx="4133087" cy="603504"/>
           </a:xfrm>
           <a:prstGeom prst="rect">
@@ -21625,186 +21794,6 @@
                 <a:latin typeface="Arial"/>
               </a:rPr>
               <a:t>Every row records what happened to one picture, including those that failed to arrive.</a:t>
-            </a:r>
-          </a:p>
-        </p:txBody>
-      </p:sp>
-      <p:sp>
-        <p:nvSpPr>
-          <p:cNvPr id="20" name="Rectangle 19"/>
-          <p:cNvSpPr/>
-          <p:nvPr/>
-        </p:nvSpPr>
-        <p:spPr>
-          <a:xfrm>
-            <a:off x="7260336" y="1700784"/>
-            <a:ext cx="4279392" cy="3840480"/>
-          </a:xfrm>
-          <a:prstGeom prst="rect">
-            <a:avLst/>
-          </a:prstGeom>
-          <a:solidFill>
-            <a:srgbClr val="FFFFFF"/>
-          </a:solidFill>
-          <a:ln w="11430">
-            <a:solidFill>
-              <a:srgbClr val="777777"/>
-            </a:solidFill>
-          </a:ln>
-        </p:spPr>
-        <p:style>
-          <a:lnRef idx="1">
-            <a:schemeClr val="accent1"/>
-          </a:lnRef>
-          <a:fillRef idx="3">
-            <a:schemeClr val="accent1"/>
-          </a:fillRef>
-          <a:effectRef idx="2">
-            <a:schemeClr val="accent1"/>
-          </a:effectRef>
-          <a:fontRef idx="minor">
-            <a:schemeClr val="lt1"/>
-          </a:fontRef>
-        </p:style>
-        <p:txBody>
-          <a:bodyPr rtlCol="0" anchor="ctr"/>
-          <a:lstStyle/>
-          <a:p>
-            <a:pPr algn="ctr"/>
-          </a:p>
-        </p:txBody>
-      </p:sp>
-      <p:sp>
-        <p:nvSpPr>
-          <p:cNvPr id="21" name="TextBox 20"/>
-          <p:cNvSpPr txBox="1"/>
-          <p:nvPr/>
-        </p:nvSpPr>
-        <p:spPr>
-          <a:xfrm>
-            <a:off x="7479792" y="1883664"/>
-            <a:ext cx="3840480" cy="256032"/>
-          </a:xfrm>
-          <a:prstGeom prst="rect">
-            <a:avLst/>
-          </a:prstGeom>
-          <a:noFill/>
-        </p:spPr>
-        <p:txBody>
-          <a:bodyPr wrap="square" lIns="45720" rIns="45720" anchor="t">
-            <a:spAutoFit/>
-          </a:bodyPr>
-          <a:lstStyle/>
-          <a:p>
-            <a:pPr algn="l">
-              <a:lnSpc>
-                <a:spcPct val="100000"/>
-              </a:lnSpc>
-              <a:spcBef>
-                <a:spcPts val="0"/>
-              </a:spcBef>
-              <a:spcAft>
-                <a:spcPts val="0"/>
-              </a:spcAft>
-            </a:pPr>
-            <a:r>
-              <a:rPr sz="1300" b="1" i="0">
-                <a:solidFill>
-                  <a:srgbClr val="111111"/>
-                </a:solidFill>
-                <a:latin typeface="Arial"/>
-              </a:rPr>
-              <a:t>How these are scored</a:t>
-            </a:r>
-          </a:p>
-        </p:txBody>
-      </p:sp>
-      <p:sp>
-        <p:nvSpPr>
-          <p:cNvPr id="22" name="TextBox 21"/>
-          <p:cNvSpPr txBox="1"/>
-          <p:nvPr/>
-        </p:nvSpPr>
-        <p:spPr>
-          <a:xfrm>
-            <a:off x="7479792" y="2286000"/>
-            <a:ext cx="3840480" cy="914400"/>
-          </a:xfrm>
-          <a:prstGeom prst="rect">
-            <a:avLst/>
-          </a:prstGeom>
-          <a:noFill/>
-        </p:spPr>
-        <p:txBody>
-          <a:bodyPr wrap="square" lIns="45720" rIns="45720" anchor="t">
-            <a:spAutoFit/>
-          </a:bodyPr>
-          <a:lstStyle/>
-          <a:p>
-            <a:pPr algn="l">
-              <a:lnSpc>
-                <a:spcPct val="100000"/>
-              </a:lnSpc>
-              <a:spcBef>
-                <a:spcPts val="0"/>
-              </a:spcBef>
-              <a:spcAft>
-                <a:spcPts val="0"/>
-              </a:spcAft>
-            </a:pPr>
-            <a:r>
-              <a:rPr sz="1600" b="1" i="0">
-                <a:solidFill>
-                  <a:srgbClr val="111111"/>
-                </a:solidFill>
-                <a:latin typeface="Arial"/>
-              </a:rPr>
-              <a:t>The rubric scores whether this list was completed.</a:t>
-            </a:r>
-          </a:p>
-        </p:txBody>
-      </p:sp>
-      <p:sp>
-        <p:nvSpPr>
-          <p:cNvPr id="23" name="TextBox 22"/>
-          <p:cNvSpPr txBox="1"/>
-          <p:nvPr/>
-        </p:nvSpPr>
-        <p:spPr>
-          <a:xfrm>
-            <a:off x="7479792" y="3310128"/>
-            <a:ext cx="3840480" cy="1737360"/>
-          </a:xfrm>
-          <a:prstGeom prst="rect">
-            <a:avLst/>
-          </a:prstGeom>
-          <a:noFill/>
-        </p:spPr>
-        <p:txBody>
-          <a:bodyPr wrap="square" lIns="45720" rIns="45720" anchor="t">
-            <a:spAutoFit/>
-          </a:bodyPr>
-          <a:lstStyle/>
-          <a:p>
-            <a:pPr algn="l">
-              <a:lnSpc>
-                <a:spcPct val="100000"/>
-              </a:lnSpc>
-              <a:spcBef>
-                <a:spcPts val="0"/>
-              </a:spcBef>
-              <a:spcAft>
-                <a:spcPts val="0"/>
-              </a:spcAft>
-            </a:pPr>
-            <a:r>
-              <a:rPr sz="1100" b="0" i="0">
-                <a:solidFill>
-                  <a:srgbClr val="555555"/>
-                </a:solidFill>
-                <a:latin typeface="Arial"/>
-              </a:rPr>
-              <a:t>Completion is independent of which way the curve went. A crossing and the learned system winning everywhere both finish the list on the left.</a:t>
             </a:r>
           </a:p>
         </p:txBody>
@@ -21988,7 +21977,7 @@
 </file>
 
 <file path=ppt/slides/slide4.xml><?xml version="1.0" encoding="utf-8"?>
-<p:sld xmlns:a="http://schemas.openxmlformats.org/drawingml/2006/main" xmlns:p="http://schemas.openxmlformats.org/presentationml/2006/main" xmlns:r="http://schemas.openxmlformats.org/officeDocument/2006/relationships">
+<p:sld xmlns:a="http://schemas.openxmlformats.org/drawingml/2006/main" xmlns:r="http://schemas.openxmlformats.org/officeDocument/2006/relationships" xmlns:p="http://schemas.openxmlformats.org/presentationml/2006/main" show="0">
   <p:cSld>
     <p:bg>
       <p:bgPr>
@@ -22004,7 +21993,14 @@
         <p:cNvGrpSpPr/>
         <p:nvPr/>
       </p:nvGrpSpPr>
-      <p:grpSpPr/>
+      <p:grpSpPr>
+        <a:xfrm>
+          <a:off x="0" y="0"/>
+          <a:ext cx="0" cy="0"/>
+          <a:chOff x="0" y="0"/>
+          <a:chExt cx="0" cy="0"/>
+        </a:xfrm>
+      </p:grpSpPr>
       <p:sp>
         <p:nvSpPr>
           <p:cNvPr id="2" name="TextBox 1"/>
@@ -22039,14 +22035,20 @@
               </a:spcAft>
             </a:pPr>
             <a:r>
-              <a:rPr sz="2700" b="1" i="0">
+              <a:rPr lang="en-US" sz="2700" b="1" i="0" dirty="0">
                 <a:solidFill>
                   <a:srgbClr val="111111"/>
                 </a:solidFill>
                 <a:latin typeface="Arial"/>
               </a:rPr>
-              <a:t>Before the numbers, one picture</a:t>
-            </a:r>
+              <a:t>Terminology</a:t>
+            </a:r>
+            <a:endParaRPr sz="2700" b="1" i="0" dirty="0">
+              <a:solidFill>
+                <a:srgbClr val="111111"/>
+              </a:solidFill>
+              <a:latin typeface="Arial"/>
+            </a:endParaRPr>
           </a:p>
         </p:txBody>
       </p:sp>
@@ -22172,6 +22174,7 @@
           <a:lstStyle/>
           <a:p>
             <a:pPr algn="ctr"/>
+            <a:endParaRPr/>
           </a:p>
         </p:txBody>
       </p:sp>
@@ -22352,6 +22355,7 @@
           <a:lstStyle/>
           <a:p>
             <a:pPr algn="ctr"/>
+            <a:endParaRPr/>
           </a:p>
         </p:txBody>
       </p:sp>
@@ -22532,6 +22536,7 @@
           <a:lstStyle/>
           <a:p>
             <a:pPr algn="ctr"/>
+            <a:endParaRPr/>
           </a:p>
         </p:txBody>
       </p:sp>
@@ -22712,6 +22717,7 @@
           <a:lstStyle/>
           <a:p>
             <a:pPr algn="ctr"/>
+            <a:endParaRPr/>
           </a:p>
         </p:txBody>
       </p:sp>
@@ -22892,6 +22898,7 @@
           <a:lstStyle/>
           <a:p>
             <a:pPr algn="ctr"/>
+            <a:endParaRPr/>
           </a:p>
         </p:txBody>
       </p:sp>
@@ -23108,7 +23115,7 @@
         </p:nvSpPr>
         <p:spPr>
           <a:xfrm>
-            <a:off x="658368" y="3968496"/>
+            <a:off x="658368" y="4160520"/>
             <a:ext cx="7818120" cy="256032"/>
           </a:xfrm>
           <a:prstGeom prst="rect">
@@ -23134,7 +23141,7 @@
               </a:spcAft>
             </a:pPr>
             <a:r>
-              <a:rPr sz="1150" b="1" i="0">
+              <a:rPr sz="1150" b="1" i="0" dirty="0">
                 <a:solidFill>
                   <a:srgbClr val="111111"/>
                 </a:solidFill>
@@ -23187,6 +23194,7 @@
           <a:lstStyle/>
           <a:p>
             <a:pPr algn="ctr"/>
+            <a:endParaRPr/>
           </a:p>
         </p:txBody>
       </p:sp>
@@ -23595,7 +23603,7 @@
 </file>
 
 <file path=ppt/slides/slide5.xml><?xml version="1.0" encoding="utf-8"?>
-<p:sld xmlns:a="http://schemas.openxmlformats.org/drawingml/2006/main" xmlns:p="http://schemas.openxmlformats.org/presentationml/2006/main" xmlns:r="http://schemas.openxmlformats.org/officeDocument/2006/relationships">
+<p:sld xmlns:a="http://schemas.openxmlformats.org/drawingml/2006/main" xmlns:r="http://schemas.openxmlformats.org/officeDocument/2006/relationships" xmlns:p="http://schemas.openxmlformats.org/presentationml/2006/main">
   <p:cSld>
     <p:bg>
       <p:bgPr>
@@ -23611,7 +23619,14 @@
         <p:cNvGrpSpPr/>
         <p:nvPr/>
       </p:nvGrpSpPr>
-      <p:grpSpPr/>
+      <p:grpSpPr>
+        <a:xfrm>
+          <a:off x="0" y="0"/>
+          <a:ext cx="0" cy="0"/>
+          <a:chOff x="0" y="0"/>
+          <a:chExt cx="0" cy="0"/>
+        </a:xfrm>
+      </p:grpSpPr>
       <p:sp>
         <p:nvSpPr>
           <p:cNvPr id="2" name="TextBox 1"/>
@@ -23779,6 +23794,7 @@
           <a:lstStyle/>
           <a:p>
             <a:pPr algn="ctr"/>
+            <a:endParaRPr/>
           </a:p>
         </p:txBody>
       </p:sp>
@@ -23959,6 +23975,7 @@
           <a:lstStyle/>
           <a:p>
             <a:pPr algn="ctr"/>
+            <a:endParaRPr/>
           </a:p>
         </p:txBody>
       </p:sp>
@@ -24139,6 +24156,7 @@
           <a:lstStyle/>
           <a:p>
             <a:pPr algn="ctr"/>
+            <a:endParaRPr/>
           </a:p>
         </p:txBody>
       </p:sp>
@@ -24319,6 +24337,7 @@
           <a:lstStyle/>
           <a:p>
             <a:pPr algn="ctr"/>
+            <a:endParaRPr/>
           </a:p>
         </p:txBody>
       </p:sp>
@@ -24499,6 +24518,7 @@
           <a:lstStyle/>
           <a:p>
             <a:pPr algn="ctr"/>
+            <a:endParaRPr/>
           </a:p>
         </p:txBody>
       </p:sp>
@@ -24679,6 +24699,7 @@
           <a:lstStyle/>
           <a:p>
             <a:pPr algn="ctr"/>
+            <a:endParaRPr/>
           </a:p>
         </p:txBody>
       </p:sp>
@@ -25361,7 +25382,7 @@
 </file>
 
 <file path=ppt/slides/slide6.xml><?xml version="1.0" encoding="utf-8"?>
-<p:sld xmlns:a="http://schemas.openxmlformats.org/drawingml/2006/main" xmlns:p="http://schemas.openxmlformats.org/presentationml/2006/main" xmlns:r="http://schemas.openxmlformats.org/officeDocument/2006/relationships">
+<p:sld xmlns:a="http://schemas.openxmlformats.org/drawingml/2006/main" xmlns:r="http://schemas.openxmlformats.org/officeDocument/2006/relationships" xmlns:p="http://schemas.openxmlformats.org/presentationml/2006/main">
   <p:cSld>
     <p:bg>
       <p:bgPr>
@@ -25377,7 +25398,14 @@
         <p:cNvGrpSpPr/>
         <p:nvPr/>
       </p:nvGrpSpPr>
-      <p:grpSpPr/>
+      <p:grpSpPr>
+        <a:xfrm>
+          <a:off x="0" y="0"/>
+          <a:ext cx="0" cy="0"/>
+          <a:chOff x="0" y="0"/>
+          <a:chExt cx="0" cy="0"/>
+        </a:xfrm>
+      </p:grpSpPr>
       <p:sp>
         <p:nvSpPr>
           <p:cNvPr id="2" name="TextBox 1"/>
@@ -25590,6 +25618,7 @@
           <a:lstStyle/>
           <a:p>
             <a:pPr algn="ctr"/>
+            <a:endParaRPr/>
           </a:p>
         </p:txBody>
       </p:sp>
@@ -25725,6 +25754,7 @@
           <a:lstStyle/>
           <a:p>
             <a:pPr algn="ctr"/>
+            <a:endParaRPr/>
           </a:p>
         </p:txBody>
       </p:sp>
@@ -25860,6 +25890,7 @@
           <a:lstStyle/>
           <a:p>
             <a:pPr algn="ctr"/>
+            <a:endParaRPr/>
           </a:p>
         </p:txBody>
       </p:sp>
@@ -25995,6 +26026,7 @@
           <a:lstStyle/>
           <a:p>
             <a:pPr algn="ctr"/>
+            <a:endParaRPr/>
           </a:p>
         </p:txBody>
       </p:sp>
@@ -26130,6 +26162,7 @@
           <a:lstStyle/>
           <a:p>
             <a:pPr algn="ctr"/>
+            <a:endParaRPr/>
           </a:p>
         </p:txBody>
       </p:sp>
@@ -26265,6 +26298,7 @@
           <a:lstStyle/>
           <a:p>
             <a:pPr algn="ctr"/>
+            <a:endParaRPr/>
           </a:p>
         </p:txBody>
       </p:sp>
@@ -26400,6 +26434,7 @@
           <a:lstStyle/>
           <a:p>
             <a:pPr algn="ctr"/>
+            <a:endParaRPr/>
           </a:p>
         </p:txBody>
       </p:sp>
@@ -26615,6 +26650,7 @@
           <a:lstStyle/>
           <a:p>
             <a:pPr algn="ctr"/>
+            <a:endParaRPr/>
           </a:p>
         </p:txBody>
       </p:sp>
@@ -26750,6 +26786,7 @@
           <a:lstStyle/>
           <a:p>
             <a:pPr algn="ctr"/>
+            <a:endParaRPr/>
           </a:p>
         </p:txBody>
       </p:sp>
@@ -26885,6 +26922,7 @@
           <a:lstStyle/>
           <a:p>
             <a:pPr algn="ctr"/>
+            <a:endParaRPr/>
           </a:p>
         </p:txBody>
       </p:sp>
@@ -27020,6 +27058,7 @@
           <a:lstStyle/>
           <a:p>
             <a:pPr algn="ctr"/>
+            <a:endParaRPr/>
           </a:p>
         </p:txBody>
       </p:sp>
@@ -27155,6 +27194,7 @@
           <a:lstStyle/>
           <a:p>
             <a:pPr algn="ctr"/>
+            <a:endParaRPr/>
           </a:p>
         </p:txBody>
       </p:sp>
@@ -27290,6 +27330,7 @@
           <a:lstStyle/>
           <a:p>
             <a:pPr algn="ctr"/>
+            <a:endParaRPr/>
           </a:p>
         </p:txBody>
       </p:sp>
@@ -27425,6 +27466,7 @@
           <a:lstStyle/>
           <a:p>
             <a:pPr algn="ctr"/>
+            <a:endParaRPr/>
           </a:p>
         </p:txBody>
       </p:sp>
@@ -27982,7 +28024,7 @@
 </file>
 
 <file path=ppt/slides/slide7.xml><?xml version="1.0" encoding="utf-8"?>
-<p:sld xmlns:a="http://schemas.openxmlformats.org/drawingml/2006/main" xmlns:p="http://schemas.openxmlformats.org/presentationml/2006/main" xmlns:r="http://schemas.openxmlformats.org/officeDocument/2006/relationships">
+<p:sld xmlns:a="http://schemas.openxmlformats.org/drawingml/2006/main" xmlns:r="http://schemas.openxmlformats.org/officeDocument/2006/relationships" xmlns:p="http://schemas.openxmlformats.org/presentationml/2006/main">
   <p:cSld>
     <p:bg>
       <p:bgPr>
@@ -27998,7 +28040,14 @@
         <p:cNvGrpSpPr/>
         <p:nvPr/>
       </p:nvGrpSpPr>
-      <p:grpSpPr/>
+      <p:grpSpPr>
+        <a:xfrm>
+          <a:off x="0" y="0"/>
+          <a:ext cx="0" cy="0"/>
+          <a:chOff x="0" y="0"/>
+          <a:chExt cx="0" cy="0"/>
+        </a:xfrm>
+      </p:grpSpPr>
       <p:sp>
         <p:nvSpPr>
           <p:cNvPr id="2" name="TextBox 1"/>
@@ -28407,7 +28456,7 @@
 </file>
 
 <file path=ppt/slides/slide8.xml><?xml version="1.0" encoding="utf-8"?>
-<p:sld xmlns:a="http://schemas.openxmlformats.org/drawingml/2006/main" xmlns:p="http://schemas.openxmlformats.org/presentationml/2006/main" xmlns:r="http://schemas.openxmlformats.org/officeDocument/2006/relationships">
+<p:sld xmlns:a="http://schemas.openxmlformats.org/drawingml/2006/main" xmlns:r="http://schemas.openxmlformats.org/officeDocument/2006/relationships" xmlns:p="http://schemas.openxmlformats.org/presentationml/2006/main">
   <p:cSld>
     <p:bg>
       <p:bgPr>
@@ -28423,7 +28472,14 @@
         <p:cNvGrpSpPr/>
         <p:nvPr/>
       </p:nvGrpSpPr>
-      <p:grpSpPr/>
+      <p:grpSpPr>
+        <a:xfrm>
+          <a:off x="0" y="0"/>
+          <a:ext cx="0" cy="0"/>
+          <a:chOff x="0" y="0"/>
+          <a:chExt cx="0" cy="0"/>
+        </a:xfrm>
+      </p:grpSpPr>
       <p:sp>
         <p:nvSpPr>
           <p:cNvPr id="2" name="TextBox 1"/>
@@ -29092,7 +29148,7 @@
 </file>
 
 <file path=ppt/slides/slide9.xml><?xml version="1.0" encoding="utf-8"?>
-<p:sld xmlns:a="http://schemas.openxmlformats.org/drawingml/2006/main" xmlns:p="http://schemas.openxmlformats.org/presentationml/2006/main" xmlns:r="http://schemas.openxmlformats.org/officeDocument/2006/relationships">
+<p:sld xmlns:a="http://schemas.openxmlformats.org/drawingml/2006/main" xmlns:r="http://schemas.openxmlformats.org/officeDocument/2006/relationships" xmlns:p="http://schemas.openxmlformats.org/presentationml/2006/main">
   <p:cSld>
     <p:bg>
       <p:bgPr>
@@ -29108,7 +29164,14 @@
         <p:cNvGrpSpPr/>
         <p:nvPr/>
       </p:nvGrpSpPr>
-      <p:grpSpPr/>
+      <p:grpSpPr>
+        <a:xfrm>
+          <a:off x="0" y="0"/>
+          <a:ext cx="0" cy="0"/>
+          <a:chOff x="0" y="0"/>
+          <a:chExt cx="0" cy="0"/>
+        </a:xfrm>
+      </p:grpSpPr>
       <p:sp>
         <p:nvSpPr>
           <p:cNvPr id="2" name="TextBox 1"/>

</xml_diff>

<commit_message>
fix(deliverables): correct claims in the Second Review deck
Edited in place so the authors' manual changes to slides 1-4 survive:
wrong months on the progress slide, the classifier "ceiling", the "easy
to beat" line, the 1/24 floor (two dB, not four), an unsourced change
count, and two novelty lines that overstated the literature. Number cells
on the tables slide no longer wrap in PowerPoint. The PDF, previews and
contact sheet are re-rendered by PowerPoint, and the presenter guide gains
an answer for "hasn't this been done before?".

Co-Authored-By: Claude Opus 5.5 <noreply@anthropic.com>
</commit_message>
<xml_diff>
--- a/deliverables/review-2/semantic-communication-second-review.pptx
+++ b/deliverables/review-2/semantic-communication-second-review.pptx
@@ -6547,7 +6547,7 @@
                 </a:solidFill>
                 <a:latin typeface="Arial"/>
               </a:rPr>
-              <a:t>A JPEG image is an easy thing to beat. This system is harder, and it is the one worth reporting.</a:t>
+              <a:t>A compressed image is one kind of digital system. This one sends what the task needs, so it is the harder test.</a:t>
             </a:r>
           </a:p>
         </p:txBody>
@@ -7545,7 +7545,7 @@
                 </a:solidFill>
                 <a:latin typeface="Arial"/>
               </a:rPr>
-              <a:t>3.000002 dB</a:t>
+              <a:t>3.0 dB</a:t>
             </a:r>
           </a:p>
         </p:txBody>
@@ -7771,7 +7771,7 @@
                 </a:solidFill>
                 <a:latin typeface="Arial"/>
               </a:rPr>
-              <a:t>20.059284 dB</a:t>
+              <a:t>20.1 dB</a:t>
             </a:r>
           </a:p>
         </p:txBody>
@@ -9269,7 +9269,7 @@
           <a:noFill/>
         </p:spPr>
         <p:txBody>
-          <a:bodyPr wrap="square" lIns="45720" rIns="45720" anchor="ctr">
+          <a:bodyPr wrap="none" lIns="0" rIns="0" anchor="ctr">
             <a:spAutoFit/>
           </a:bodyPr>
           <a:lstStyle/>
@@ -9314,7 +9314,7 @@
           <a:noFill/>
         </p:spPr>
         <p:txBody>
-          <a:bodyPr wrap="square" lIns="45720" rIns="45720" anchor="ctr">
+          <a:bodyPr wrap="none" lIns="0" rIns="0" anchor="ctr">
             <a:spAutoFit/>
           </a:bodyPr>
           <a:lstStyle/>
@@ -9359,7 +9359,7 @@
           <a:noFill/>
         </p:spPr>
         <p:txBody>
-          <a:bodyPr wrap="square" lIns="45720" rIns="45720" anchor="ctr">
+          <a:bodyPr wrap="none" lIns="0" rIns="0" anchor="ctr">
             <a:spAutoFit/>
           </a:bodyPr>
           <a:lstStyle/>
@@ -9404,7 +9404,7 @@
           <a:noFill/>
         </p:spPr>
         <p:txBody>
-          <a:bodyPr wrap="square" lIns="45720" rIns="45720" anchor="ctr">
+          <a:bodyPr wrap="none" lIns="0" rIns="0" anchor="ctr">
             <a:spAutoFit/>
           </a:bodyPr>
           <a:lstStyle/>
@@ -9449,7 +9449,7 @@
           <a:noFill/>
         </p:spPr>
         <p:txBody>
-          <a:bodyPr wrap="square" lIns="45720" rIns="45720" anchor="ctr">
+          <a:bodyPr wrap="none" lIns="0" rIns="0" anchor="ctr">
             <a:spAutoFit/>
           </a:bodyPr>
           <a:lstStyle/>
@@ -9494,7 +9494,7 @@
           <a:noFill/>
         </p:spPr>
         <p:txBody>
-          <a:bodyPr wrap="square" lIns="45720" rIns="45720" anchor="ctr">
+          <a:bodyPr wrap="none" lIns="0" rIns="0" anchor="ctr">
             <a:spAutoFit/>
           </a:bodyPr>
           <a:lstStyle/>
@@ -9630,7 +9630,7 @@
           <a:noFill/>
         </p:spPr>
         <p:txBody>
-          <a:bodyPr wrap="square" lIns="45720" rIns="45720" anchor="ctr">
+          <a:bodyPr wrap="none" lIns="0" rIns="0" anchor="ctr">
             <a:spAutoFit/>
           </a:bodyPr>
           <a:lstStyle/>
@@ -9675,7 +9675,7 @@
           <a:noFill/>
         </p:spPr>
         <p:txBody>
-          <a:bodyPr wrap="square" lIns="45720" rIns="45720" anchor="ctr">
+          <a:bodyPr wrap="none" lIns="0" rIns="0" anchor="ctr">
             <a:spAutoFit/>
           </a:bodyPr>
           <a:lstStyle/>
@@ -9720,7 +9720,7 @@
           <a:noFill/>
         </p:spPr>
         <p:txBody>
-          <a:bodyPr wrap="square" lIns="45720" rIns="45720" anchor="ctr">
+          <a:bodyPr wrap="none" lIns="0" rIns="0" anchor="ctr">
             <a:spAutoFit/>
           </a:bodyPr>
           <a:lstStyle/>
@@ -9765,7 +9765,7 @@
           <a:noFill/>
         </p:spPr>
         <p:txBody>
-          <a:bodyPr wrap="square" lIns="45720" rIns="45720" anchor="ctr">
+          <a:bodyPr wrap="none" lIns="0" rIns="0" anchor="ctr">
             <a:spAutoFit/>
           </a:bodyPr>
           <a:lstStyle/>
@@ -9810,7 +9810,7 @@
           <a:noFill/>
         </p:spPr>
         <p:txBody>
-          <a:bodyPr wrap="square" lIns="45720" rIns="45720" anchor="ctr">
+          <a:bodyPr wrap="none" lIns="0" rIns="0" anchor="ctr">
             <a:spAutoFit/>
           </a:bodyPr>
           <a:lstStyle/>
@@ -9855,7 +9855,7 @@
           <a:noFill/>
         </p:spPr>
         <p:txBody>
-          <a:bodyPr wrap="square" lIns="45720" rIns="45720" anchor="ctr">
+          <a:bodyPr wrap="none" lIns="0" rIns="0" anchor="ctr">
             <a:spAutoFit/>
           </a:bodyPr>
           <a:lstStyle/>
@@ -9991,7 +9991,7 @@
           <a:noFill/>
         </p:spPr>
         <p:txBody>
-          <a:bodyPr wrap="square" lIns="45720" rIns="45720" anchor="ctr">
+          <a:bodyPr wrap="none" lIns="0" rIns="0" anchor="ctr">
             <a:spAutoFit/>
           </a:bodyPr>
           <a:lstStyle/>
@@ -10036,7 +10036,7 @@
           <a:noFill/>
         </p:spPr>
         <p:txBody>
-          <a:bodyPr wrap="square" lIns="45720" rIns="45720" anchor="ctr">
+          <a:bodyPr wrap="none" lIns="0" rIns="0" anchor="ctr">
             <a:spAutoFit/>
           </a:bodyPr>
           <a:lstStyle/>
@@ -10081,7 +10081,7 @@
           <a:noFill/>
         </p:spPr>
         <p:txBody>
-          <a:bodyPr wrap="square" lIns="45720" rIns="45720" anchor="ctr">
+          <a:bodyPr wrap="none" lIns="0" rIns="0" anchor="ctr">
             <a:spAutoFit/>
           </a:bodyPr>
           <a:lstStyle/>
@@ -10126,7 +10126,7 @@
           <a:noFill/>
         </p:spPr>
         <p:txBody>
-          <a:bodyPr wrap="square" lIns="45720" rIns="45720" anchor="ctr">
+          <a:bodyPr wrap="none" lIns="0" rIns="0" anchor="ctr">
             <a:spAutoFit/>
           </a:bodyPr>
           <a:lstStyle/>
@@ -10171,7 +10171,7 @@
           <a:noFill/>
         </p:spPr>
         <p:txBody>
-          <a:bodyPr wrap="square" lIns="45720" rIns="45720" anchor="ctr">
+          <a:bodyPr wrap="none" lIns="0" rIns="0" anchor="ctr">
             <a:spAutoFit/>
           </a:bodyPr>
           <a:lstStyle/>
@@ -10216,7 +10216,7 @@
           <a:noFill/>
         </p:spPr>
         <p:txBody>
-          <a:bodyPr wrap="square" lIns="45720" rIns="45720" anchor="ctr">
+          <a:bodyPr wrap="none" lIns="0" rIns="0" anchor="ctr">
             <a:spAutoFit/>
           </a:bodyPr>
           <a:lstStyle/>
@@ -10352,7 +10352,7 @@
           <a:noFill/>
         </p:spPr>
         <p:txBody>
-          <a:bodyPr wrap="square" lIns="45720" rIns="45720" anchor="ctr">
+          <a:bodyPr wrap="none" lIns="0" rIns="0" anchor="ctr">
             <a:spAutoFit/>
           </a:bodyPr>
           <a:lstStyle/>
@@ -10397,7 +10397,7 @@
           <a:noFill/>
         </p:spPr>
         <p:txBody>
-          <a:bodyPr wrap="square" lIns="45720" rIns="45720" anchor="ctr">
+          <a:bodyPr wrap="none" lIns="0" rIns="0" anchor="ctr">
             <a:spAutoFit/>
           </a:bodyPr>
           <a:lstStyle/>
@@ -10442,7 +10442,7 @@
           <a:noFill/>
         </p:spPr>
         <p:txBody>
-          <a:bodyPr wrap="square" lIns="45720" rIns="45720" anchor="ctr">
+          <a:bodyPr wrap="none" lIns="0" rIns="0" anchor="ctr">
             <a:spAutoFit/>
           </a:bodyPr>
           <a:lstStyle/>
@@ -10487,7 +10487,7 @@
           <a:noFill/>
         </p:spPr>
         <p:txBody>
-          <a:bodyPr wrap="square" lIns="45720" rIns="45720" anchor="ctr">
+          <a:bodyPr wrap="none" lIns="0" rIns="0" anchor="ctr">
             <a:spAutoFit/>
           </a:bodyPr>
           <a:lstStyle/>
@@ -10532,7 +10532,7 @@
           <a:noFill/>
         </p:spPr>
         <p:txBody>
-          <a:bodyPr wrap="square" lIns="45720" rIns="45720" anchor="ctr">
+          <a:bodyPr wrap="none" lIns="0" rIns="0" anchor="ctr">
             <a:spAutoFit/>
           </a:bodyPr>
           <a:lstStyle/>
@@ -10577,7 +10577,7 @@
           <a:noFill/>
         </p:spPr>
         <p:txBody>
-          <a:bodyPr wrap="square" lIns="45720" rIns="45720" anchor="ctr">
+          <a:bodyPr wrap="none" lIns="0" rIns="0" anchor="ctr">
             <a:spAutoFit/>
           </a:bodyPr>
           <a:lstStyle/>
@@ -10713,7 +10713,7 @@
           <a:noFill/>
         </p:spPr>
         <p:txBody>
-          <a:bodyPr wrap="square" lIns="45720" rIns="45720" anchor="ctr">
+          <a:bodyPr wrap="none" lIns="0" rIns="0" anchor="ctr">
             <a:spAutoFit/>
           </a:bodyPr>
           <a:lstStyle/>
@@ -10758,7 +10758,7 @@
           <a:noFill/>
         </p:spPr>
         <p:txBody>
-          <a:bodyPr wrap="square" lIns="45720" rIns="45720" anchor="ctr">
+          <a:bodyPr wrap="none" lIns="0" rIns="0" anchor="ctr">
             <a:spAutoFit/>
           </a:bodyPr>
           <a:lstStyle/>
@@ -10803,7 +10803,7 @@
           <a:noFill/>
         </p:spPr>
         <p:txBody>
-          <a:bodyPr wrap="square" lIns="45720" rIns="45720" anchor="ctr">
+          <a:bodyPr wrap="none" lIns="0" rIns="0" anchor="ctr">
             <a:spAutoFit/>
           </a:bodyPr>
           <a:lstStyle/>
@@ -10848,7 +10848,7 @@
           <a:noFill/>
         </p:spPr>
         <p:txBody>
-          <a:bodyPr wrap="square" lIns="45720" rIns="45720" anchor="ctr">
+          <a:bodyPr wrap="none" lIns="0" rIns="0" anchor="ctr">
             <a:spAutoFit/>
           </a:bodyPr>
           <a:lstStyle/>
@@ -10893,7 +10893,7 @@
           <a:noFill/>
         </p:spPr>
         <p:txBody>
-          <a:bodyPr wrap="square" lIns="45720" rIns="45720" anchor="ctr">
+          <a:bodyPr wrap="none" lIns="0" rIns="0" anchor="ctr">
             <a:spAutoFit/>
           </a:bodyPr>
           <a:lstStyle/>
@@ -10938,7 +10938,7 @@
           <a:noFill/>
         </p:spPr>
         <p:txBody>
-          <a:bodyPr wrap="square" lIns="45720" rIns="45720" anchor="ctr">
+          <a:bodyPr wrap="none" lIns="0" rIns="0" anchor="ctr">
             <a:spAutoFit/>
           </a:bodyPr>
           <a:lstStyle/>
@@ -11074,7 +11074,7 @@
           <a:noFill/>
         </p:spPr>
         <p:txBody>
-          <a:bodyPr wrap="square" lIns="45720" rIns="45720" anchor="ctr">
+          <a:bodyPr wrap="none" lIns="0" rIns="0" anchor="ctr">
             <a:spAutoFit/>
           </a:bodyPr>
           <a:lstStyle/>
@@ -11119,7 +11119,7 @@
           <a:noFill/>
         </p:spPr>
         <p:txBody>
-          <a:bodyPr wrap="square" lIns="45720" rIns="45720" anchor="ctr">
+          <a:bodyPr wrap="none" lIns="0" rIns="0" anchor="ctr">
             <a:spAutoFit/>
           </a:bodyPr>
           <a:lstStyle/>
@@ -11164,7 +11164,7 @@
           <a:noFill/>
         </p:spPr>
         <p:txBody>
-          <a:bodyPr wrap="square" lIns="45720" rIns="45720" anchor="ctr">
+          <a:bodyPr wrap="none" lIns="0" rIns="0" anchor="ctr">
             <a:spAutoFit/>
           </a:bodyPr>
           <a:lstStyle/>
@@ -11209,7 +11209,7 @@
           <a:noFill/>
         </p:spPr>
         <p:txBody>
-          <a:bodyPr wrap="square" lIns="45720" rIns="45720" anchor="ctr">
+          <a:bodyPr wrap="none" lIns="0" rIns="0" anchor="ctr">
             <a:spAutoFit/>
           </a:bodyPr>
           <a:lstStyle/>
@@ -11254,7 +11254,7 @@
           <a:noFill/>
         </p:spPr>
         <p:txBody>
-          <a:bodyPr wrap="square" lIns="45720" rIns="45720" anchor="ctr">
+          <a:bodyPr wrap="none" lIns="0" rIns="0" anchor="ctr">
             <a:spAutoFit/>
           </a:bodyPr>
           <a:lstStyle/>
@@ -11299,7 +11299,7 @@
           <a:noFill/>
         </p:spPr>
         <p:txBody>
-          <a:bodyPr wrap="square" lIns="45720" rIns="45720" anchor="ctr">
+          <a:bodyPr wrap="none" lIns="0" rIns="0" anchor="ctr">
             <a:spAutoFit/>
           </a:bodyPr>
           <a:lstStyle/>
@@ -11690,7 +11690,7 @@
           <a:noFill/>
         </p:spPr>
         <p:txBody>
-          <a:bodyPr wrap="square" lIns="45720" rIns="45720" anchor="ctr">
+          <a:bodyPr wrap="none" lIns="0" rIns="0" anchor="ctr">
             <a:spAutoFit/>
           </a:bodyPr>
           <a:lstStyle/>
@@ -11735,7 +11735,7 @@
           <a:noFill/>
         </p:spPr>
         <p:txBody>
-          <a:bodyPr wrap="square" lIns="45720" rIns="45720" anchor="ctr">
+          <a:bodyPr wrap="none" lIns="0" rIns="0" anchor="ctr">
             <a:spAutoFit/>
           </a:bodyPr>
           <a:lstStyle/>
@@ -11780,7 +11780,7 @@
           <a:noFill/>
         </p:spPr>
         <p:txBody>
-          <a:bodyPr wrap="square" lIns="45720" rIns="45720" anchor="ctr">
+          <a:bodyPr wrap="none" lIns="0" rIns="0" anchor="ctr">
             <a:spAutoFit/>
           </a:bodyPr>
           <a:lstStyle/>
@@ -11825,7 +11825,7 @@
           <a:noFill/>
         </p:spPr>
         <p:txBody>
-          <a:bodyPr wrap="square" lIns="45720" rIns="45720" anchor="ctr">
+          <a:bodyPr wrap="none" lIns="0" rIns="0" anchor="ctr">
             <a:spAutoFit/>
           </a:bodyPr>
           <a:lstStyle/>
@@ -11870,7 +11870,7 @@
           <a:noFill/>
         </p:spPr>
         <p:txBody>
-          <a:bodyPr wrap="square" lIns="45720" rIns="45720" anchor="ctr">
+          <a:bodyPr wrap="none" lIns="0" rIns="0" anchor="ctr">
             <a:spAutoFit/>
           </a:bodyPr>
           <a:lstStyle/>
@@ -11915,7 +11915,7 @@
           <a:noFill/>
         </p:spPr>
         <p:txBody>
-          <a:bodyPr wrap="square" lIns="45720" rIns="45720" anchor="ctr">
+          <a:bodyPr wrap="none" lIns="0" rIns="0" anchor="ctr">
             <a:spAutoFit/>
           </a:bodyPr>
           <a:lstStyle/>
@@ -12051,7 +12051,7 @@
           <a:noFill/>
         </p:spPr>
         <p:txBody>
-          <a:bodyPr wrap="square" lIns="45720" rIns="45720" anchor="ctr">
+          <a:bodyPr wrap="none" lIns="0" rIns="0" anchor="ctr">
             <a:spAutoFit/>
           </a:bodyPr>
           <a:lstStyle/>
@@ -12096,7 +12096,7 @@
           <a:noFill/>
         </p:spPr>
         <p:txBody>
-          <a:bodyPr wrap="square" lIns="45720" rIns="45720" anchor="ctr">
+          <a:bodyPr wrap="none" lIns="0" rIns="0" anchor="ctr">
             <a:spAutoFit/>
           </a:bodyPr>
           <a:lstStyle/>
@@ -12141,7 +12141,7 @@
           <a:noFill/>
         </p:spPr>
         <p:txBody>
-          <a:bodyPr wrap="square" lIns="45720" rIns="45720" anchor="ctr">
+          <a:bodyPr wrap="none" lIns="0" rIns="0" anchor="ctr">
             <a:spAutoFit/>
           </a:bodyPr>
           <a:lstStyle/>
@@ -12186,7 +12186,7 @@
           <a:noFill/>
         </p:spPr>
         <p:txBody>
-          <a:bodyPr wrap="square" lIns="45720" rIns="45720" anchor="ctr">
+          <a:bodyPr wrap="none" lIns="0" rIns="0" anchor="ctr">
             <a:spAutoFit/>
           </a:bodyPr>
           <a:lstStyle/>
@@ -12231,7 +12231,7 @@
           <a:noFill/>
         </p:spPr>
         <p:txBody>
-          <a:bodyPr wrap="square" lIns="45720" rIns="45720" anchor="ctr">
+          <a:bodyPr wrap="none" lIns="0" rIns="0" anchor="ctr">
             <a:spAutoFit/>
           </a:bodyPr>
           <a:lstStyle/>
@@ -12276,7 +12276,7 @@
           <a:noFill/>
         </p:spPr>
         <p:txBody>
-          <a:bodyPr wrap="square" lIns="45720" rIns="45720" anchor="ctr">
+          <a:bodyPr wrap="none" lIns="0" rIns="0" anchor="ctr">
             <a:spAutoFit/>
           </a:bodyPr>
           <a:lstStyle/>
@@ -12412,7 +12412,7 @@
           <a:noFill/>
         </p:spPr>
         <p:txBody>
-          <a:bodyPr wrap="square" lIns="45720" rIns="45720" anchor="ctr">
+          <a:bodyPr wrap="none" lIns="0" rIns="0" anchor="ctr">
             <a:spAutoFit/>
           </a:bodyPr>
           <a:lstStyle/>
@@ -12457,7 +12457,7 @@
           <a:noFill/>
         </p:spPr>
         <p:txBody>
-          <a:bodyPr wrap="square" lIns="45720" rIns="45720" anchor="ctr">
+          <a:bodyPr wrap="none" lIns="0" rIns="0" anchor="ctr">
             <a:spAutoFit/>
           </a:bodyPr>
           <a:lstStyle/>
@@ -12502,7 +12502,7 @@
           <a:noFill/>
         </p:spPr>
         <p:txBody>
-          <a:bodyPr wrap="square" lIns="45720" rIns="45720" anchor="ctr">
+          <a:bodyPr wrap="none" lIns="0" rIns="0" anchor="ctr">
             <a:spAutoFit/>
           </a:bodyPr>
           <a:lstStyle/>
@@ -12547,7 +12547,7 @@
           <a:noFill/>
         </p:spPr>
         <p:txBody>
-          <a:bodyPr wrap="square" lIns="45720" rIns="45720" anchor="ctr">
+          <a:bodyPr wrap="none" lIns="0" rIns="0" anchor="ctr">
             <a:spAutoFit/>
           </a:bodyPr>
           <a:lstStyle/>
@@ -12592,7 +12592,7 @@
           <a:noFill/>
         </p:spPr>
         <p:txBody>
-          <a:bodyPr wrap="square" lIns="45720" rIns="45720" anchor="ctr">
+          <a:bodyPr wrap="none" lIns="0" rIns="0" anchor="ctr">
             <a:spAutoFit/>
           </a:bodyPr>
           <a:lstStyle/>
@@ -12637,7 +12637,7 @@
           <a:noFill/>
         </p:spPr>
         <p:txBody>
-          <a:bodyPr wrap="square" lIns="45720" rIns="45720" anchor="ctr">
+          <a:bodyPr wrap="none" lIns="0" rIns="0" anchor="ctr">
             <a:spAutoFit/>
           </a:bodyPr>
           <a:lstStyle/>
@@ -13085,7 +13085,7 @@
                 </a:solidFill>
                 <a:latin typeface="Arial"/>
               </a:rPr>
-              <a:t>Each column is one signal strength; each cell is the number of correct labels out of the same 1,000 held-back pictures. At 1/6 rate the learned row leads up to −5 dB and the digital row leads from −4 dB. At 1/24 rate the digital row stays on the fallback floor four dB longer, then climbs past the learned row from +4 dB. The difference between the two tables is the effect of cutting radio time fourfold.</a:t>
+              <a:t>Each column is one signal strength; each cell is the number of correct labels out of the same 1,000 held-back pictures. At 1/6 rate the learned row leads up to −5 dB and the digital row leads from −4 dB. At 1/24 rate the digital row stays on the fallback floor two dB longer, then climbs past the learned row from +4 dB. The difference between the two tables is the effect of cutting radio time fourfold.</a:t>
             </a:r>
           </a:p>
         </p:txBody>
@@ -13833,7 +13833,7 @@
                 </a:solidFill>
                 <a:latin typeface="Arial"/>
               </a:rPr>
-              <a:t>Spike heights are measured on the numbers we send. Real-radio replay is scheduled for late October.</a:t>
+              <a:t>Spike heights are measured on the numbers we send. Real-radio replay is a stretch goal for late October.</a:t>
             </a:r>
           </a:p>
         </p:txBody>
@@ -15310,7 +15310,7 @@
                 </a:solidFill>
                 <a:latin typeface="Arial"/>
               </a:rPr>
-              <a:t>Twenty-two more changes were made during the project, three of them repairs to checks that were themselves wrong.</a:t>
+              <a:t>Every other change made during the project is recorded, with its reason, in the specification's amendment log.</a:t>
             </a:r>
           </a:p>
         </p:txBody>
@@ -15809,7 +15809,7 @@
                 </a:solidFill>
                 <a:latin typeface="Arial"/>
               </a:rPr>
-              <a:t>Prior work reports the gap without this control.</a:t>
+              <a:t>To our knowledge, classification studies report this gap without a matched control.</a:t>
             </a:r>
           </a:p>
         </p:txBody>
@@ -16025,7 +16025,7 @@
                 </a:solidFill>
                 <a:latin typeface="Arial"/>
               </a:rPr>
-              <a:t>Prior work quotes a nominal rate and leaves the overhead uncounted.</a:t>
+              <a:t>Many comparisons quote a nominal rate; here every framing and checksum byte is counted.</a:t>
             </a:r>
           </a:p>
         </p:txBody>
@@ -16848,7 +16848,7 @@
                 </a:solidFill>
                 <a:latin typeface="Arial"/>
               </a:rPr>
-              <a:t>Where the remaining weeks went</a:t>
+              <a:t>Where the remaining weeks go</a:t>
             </a:r>
           </a:p>
         </p:txBody>
@@ -17663,7 +17663,7 @@
                 </a:solidFill>
                 <a:latin typeface="Arial"/>
               </a:rPr>
-              <a:t>Signal-strength slider, both systems side by side, frozen plot</a:t>
+              <a:t>Already built; rehearse it with the frozen results</a:t>
             </a:r>
           </a:p>
         </p:txBody>
@@ -18931,7 +18931,7 @@
                 </a:solidFill>
                 <a:latin typeface="Arial"/>
               </a:rPr>
-              <a:t>Progress </a:t>
+              <a:t>Progress up to Sep. 30th</a:t>
             </a:r>
             <a:r>
               <a:rPr lang="en-US" sz="2700" b="1" dirty="0" err="1">
@@ -18940,7 +18940,7 @@
                 </a:solidFill>
                 <a:latin typeface="Arial"/>
               </a:rPr>
-              <a:t>upto</a:t>
+              <a:t/>
             </a:r>
             <a:r>
               <a:rPr lang="en-US" sz="2700" b="1" dirty="0">
@@ -18949,7 +18949,7 @@
                 </a:solidFill>
                 <a:latin typeface="Arial"/>
               </a:rPr>
-              <a:t> Sep. 30th</a:t>
+              <a:t/>
             </a:r>
             <a:endParaRPr sz="2700" b="1" i="0" dirty="0">
               <a:solidFill>
@@ -19851,7 +19851,7 @@
                 </a:solidFill>
                 <a:latin typeface="Arial"/>
               </a:rPr>
-              <a:t>Oct · Measurements</a:t>
+              <a:t>Sep · Measurements</a:t>
             </a:r>
           </a:p>
         </p:txBody>
@@ -19976,7 +19976,7 @@
                 </a:solidFill>
                 <a:latin typeface="Arial"/>
               </a:rPr>
-              <a:t>Nov · Exam set</a:t>
+              <a:t>Oct · Exam set</a:t>
             </a:r>
           </a:p>
         </p:txBody>
@@ -27715,7 +27715,7 @@
                 </a:solidFill>
                 <a:latin typeface="Arial"/>
               </a:rPr>
-              <a:t>ResNet-18, 11.18 M parameters, trained from scratch. It reads 89.8% of held-back pictures correctly, and that is the ceiling both systems are measured against.</a:t>
+              <a:t>ResNet-18, 11.18 M parameters, trained from scratch. It reads 89.8% of held-back pictures correctly. The digital side is marked by a copy of it retrained on compressed pictures.</a:t>
             </a:r>
           </a:p>
         </p:txBody>

</xml_diff>